<commit_message>
Format Morrison poster references in two columns
</commit_message>
<xml_diff>
--- a/outputs/posters/poster_pns_asma_morrison_en.pptx
+++ b/outputs/posters/poster_pns_asma_morrison_en.pptx
@@ -2,13 +2,13 @@
 <file path=ppt/presentation.xml><?xml version="1.0" encoding="utf-8"?>
 <p:presentation xmlns:p="http://schemas.openxmlformats.org/presentationml/2006/main">
   <p:sldMasterIdLst>
-    <p:sldMasterId xmlns:r="http://schemas.openxmlformats.org/officeDocument/2006/relationships" id="2147483648" r:id="R2da2ef1d5af344fd"/>
+    <p:sldMasterId xmlns:r="http://schemas.openxmlformats.org/officeDocument/2006/relationships" id="2147483648" r:id="R8ada595fdf254012"/>
   </p:sldMasterIdLst>
   <p:notesMasterIdLst>
-    <p:notesMasterId xmlns:r="http://schemas.openxmlformats.org/officeDocument/2006/relationships" r:id="R6d7ffd8de59a4810"/>
+    <p:notesMasterId xmlns:r="http://schemas.openxmlformats.org/officeDocument/2006/relationships" r:id="Ra3820a20b54d49f1"/>
   </p:notesMasterIdLst>
   <p:sldIdLst>
-    <p:sldId xmlns:r="http://schemas.openxmlformats.org/officeDocument/2006/relationships" id="256" r:id="Rf33a82278b664e36"/>
+    <p:sldId xmlns:r="http://schemas.openxmlformats.org/officeDocument/2006/relationships" id="256" r:id="Rf14fb708bc264b7f"/>
   </p:sldIdLst>
   <p:sldSz cx="9525000" cy="13468350"/>
   <p:notesSz cx="6858000" cy="9144000"/>
@@ -601,7 +601,7 @@
   </p:cSld>
   <p:clrMap bg1="lt1" tx1="dk1" bg2="lt2" tx2="dk2" accent1="accent1" accent2="accent2" accent3="accent3" accent4="accent4" accent5="accent5" accent6="accent6" hlink="hlink" folHlink="folHlink"/>
   <p:sldLayoutIdLst>
-    <p:sldLayoutId xmlns:r="http://schemas.openxmlformats.org/officeDocument/2006/relationships" id="2147483649" r:id="R4dc07bc70e634c0d"/>
+    <p:sldLayoutId xmlns:r="http://schemas.openxmlformats.org/officeDocument/2006/relationships" id="2147483649" r:id="R23e58f06122d43a5"/>
   </p:sldLayoutIdLst>
   <p:txStyles>
     <p:titleStyle>
@@ -1149,14 +1149,14 @@
       </p:grpSpPr>
       <p:pic>
         <p:nvPicPr>
-          <p:cNvPr id="64" name=""/>
+          <p:cNvPr id="65" name=""/>
           <p:cNvPicPr>
             <a:picLocks xmlns:a="http://schemas.openxmlformats.org/drawingml/2006/main" noChangeAspect="1"/>
           </p:cNvPicPr>
           <p:nvPr/>
         </p:nvPicPr>
         <p:blipFill>
-          <a:blip xmlns:r="http://schemas.openxmlformats.org/officeDocument/2006/relationships" xmlns:a="http://schemas.openxmlformats.org/drawingml/2006/main" r:embed="R23bc01011c684544"/>
+          <a:blip xmlns:r="http://schemas.openxmlformats.org/officeDocument/2006/relationships" xmlns:a="http://schemas.openxmlformats.org/drawingml/2006/main" r:embed="R10fe8035664d4b84"/>
           <a:srcRect xmlns:a="http://schemas.openxmlformats.org/drawingml/2006/main" l="0" t="38622" r="0" b="38622"/>
           <a:stretch xmlns:a="http://schemas.openxmlformats.org/drawingml/2006/main">
             <a:fillRect l="0" t="0" r="0" b="0"/>
@@ -1166,28 +1166,6 @@
           <a:xfrm xmlns:a="http://schemas.openxmlformats.org/drawingml/2006/main">
             <a:off x="0" y="0"/>
             <a:ext cx="9525000" cy="1219200"/>
-          </a:xfrm>
-          <a:prstGeom xmlns:a="http://schemas.openxmlformats.org/drawingml/2006/main" prst="rect">
-            <a:avLst/>
-          </a:prstGeom>
-        </p:spPr>
-      </p:pic>
-      <p:pic>
-        <p:nvPicPr>
-          <p:cNvPr id="65" name=""/>
-          <p:cNvPicPr>
-            <a:picLocks xmlns:a="http://schemas.openxmlformats.org/drawingml/2006/main" noChangeAspect="1"/>
-          </p:cNvPicPr>
-          <p:nvPr/>
-        </p:nvPicPr>
-        <p:blipFill>
-          <a:blip xmlns:r="http://schemas.openxmlformats.org/officeDocument/2006/relationships" xmlns:a="http://schemas.openxmlformats.org/drawingml/2006/main" r:embed="Rdb324d8a126448dd"/>
-          <a:stretch xmlns:a="http://schemas.openxmlformats.org/drawingml/2006/main"/>
-        </p:blipFill>
-        <p:spPr>
-          <a:xfrm xmlns:a="http://schemas.openxmlformats.org/drawingml/2006/main">
-            <a:off x="323850" y="265374"/>
-            <a:ext cx="2952750" cy="612252"/>
           </a:xfrm>
           <a:prstGeom xmlns:a="http://schemas.openxmlformats.org/drawingml/2006/main" prst="rect">
             <a:avLst/>
@@ -1203,11 +1181,33 @@
           <p:nvPr/>
         </p:nvPicPr>
         <p:blipFill>
-          <a:blip xmlns:r="http://schemas.openxmlformats.org/officeDocument/2006/relationships" xmlns:a="http://schemas.openxmlformats.org/drawingml/2006/main" r:embed="Rf0d67e9d4d674a24"/>
+          <a:blip xmlns:r="http://schemas.openxmlformats.org/officeDocument/2006/relationships" xmlns:a="http://schemas.openxmlformats.org/drawingml/2006/main" r:embed="R5596aa549d6b4f72"/>
           <a:stretch xmlns:a="http://schemas.openxmlformats.org/drawingml/2006/main"/>
         </p:blipFill>
         <p:spPr>
           <a:xfrm xmlns:a="http://schemas.openxmlformats.org/drawingml/2006/main">
+            <a:off x="323850" y="265374"/>
+            <a:ext cx="2952750" cy="612252"/>
+          </a:xfrm>
+          <a:prstGeom xmlns:a="http://schemas.openxmlformats.org/drawingml/2006/main" prst="rect">
+            <a:avLst/>
+          </a:prstGeom>
+        </p:spPr>
+      </p:pic>
+      <p:pic>
+        <p:nvPicPr>
+          <p:cNvPr id="67" name=""/>
+          <p:cNvPicPr>
+            <a:picLocks xmlns:a="http://schemas.openxmlformats.org/drawingml/2006/main" noChangeAspect="1"/>
+          </p:cNvPicPr>
+          <p:nvPr/>
+        </p:nvPicPr>
+        <p:blipFill>
+          <a:blip xmlns:r="http://schemas.openxmlformats.org/officeDocument/2006/relationships" xmlns:a="http://schemas.openxmlformats.org/drawingml/2006/main" r:embed="Rd485346d649048b6"/>
+          <a:stretch xmlns:a="http://schemas.openxmlformats.org/drawingml/2006/main"/>
+        </p:blipFill>
+        <p:spPr>
+          <a:xfrm xmlns:a="http://schemas.openxmlformats.org/drawingml/2006/main">
             <a:off x="3905250" y="425056"/>
             <a:ext cx="4953000" cy="311937"/>
           </a:xfrm>
@@ -1221,7 +1221,7 @@
           <p:cNvPr id="4" name="morrison-title">
             <a:extLst xmlns:a="http://schemas.openxmlformats.org/drawingml/2006/main">
               <a:ext uri="{FF2B5EF4-FFF2-40B4-BE49-F238E27FC236}">
-                <a16:creationId xmlns:a16="http://schemas.microsoft.com/office/drawing/2014/main" id="{142E962B-AE39-4875-B258-83253AE861AF}"/>
+                <a16:creationId xmlns:a16="http://schemas.microsoft.com/office/drawing/2014/main" id="{A37EC5BE-B84C-438D-A717-07894D4F40F1}"/>
               </a:ext>
             </a:extLst>
           </p:cNvPr>
@@ -1271,7 +1271,7 @@
           <p:cNvPr id="5" name="morrison-authors">
             <a:extLst xmlns:a="http://schemas.openxmlformats.org/drawingml/2006/main">
               <a:ext uri="{FF2B5EF4-FFF2-40B4-BE49-F238E27FC236}">
-                <a16:creationId xmlns:a16="http://schemas.microsoft.com/office/drawing/2014/main" id="{8290CFC9-914C-4594-8961-4C1FC2044E01}"/>
+                <a16:creationId xmlns:a16="http://schemas.microsoft.com/office/drawing/2014/main" id="{E614DFB2-0F89-4140-927A-1239DE340DFE}"/>
               </a:ext>
             </a:extLst>
           </p:cNvPr>
@@ -1321,7 +1321,7 @@
           <p:cNvPr id="6" name="central-message">
             <a:extLst xmlns:a="http://schemas.openxmlformats.org/drawingml/2006/main">
               <a:ext uri="{FF2B5EF4-FFF2-40B4-BE49-F238E27FC236}">
-                <a16:creationId xmlns:a16="http://schemas.microsoft.com/office/drawing/2014/main" id="{D3A3CAD2-F3B1-4570-A7C8-5B545AB6E72B}"/>
+                <a16:creationId xmlns:a16="http://schemas.microsoft.com/office/drawing/2014/main" id="{19157170-E41D-4E1A-860F-1D59C7CEAF04}"/>
               </a:ext>
             </a:extLst>
           </p:cNvPr>
@@ -1375,7 +1375,7 @@
           <p:cNvPr id="7" name="1-Method in one line-box">
             <a:extLst xmlns:a="http://schemas.openxmlformats.org/drawingml/2006/main">
               <a:ext uri="{FF2B5EF4-FFF2-40B4-BE49-F238E27FC236}">
-                <a16:creationId xmlns:a16="http://schemas.microsoft.com/office/drawing/2014/main" id="{870C86D8-0E10-4DBA-82B2-5BCEC58F73CE}"/>
+                <a16:creationId xmlns:a16="http://schemas.microsoft.com/office/drawing/2014/main" id="{2B1A9B64-A63D-4298-8B22-12B50404BD79}"/>
               </a:ext>
             </a:extLst>
           </p:cNvPr>
@@ -1408,7 +1408,7 @@
           <p:cNvPr id="8" name="1-Method in one line-head">
             <a:extLst xmlns:a="http://schemas.openxmlformats.org/drawingml/2006/main">
               <a:ext uri="{FF2B5EF4-FFF2-40B4-BE49-F238E27FC236}">
-                <a16:creationId xmlns:a16="http://schemas.microsoft.com/office/drawing/2014/main" id="{CE6880CA-76A1-4C92-BAD4-53C2AF76C7DE}"/>
+                <a16:creationId xmlns:a16="http://schemas.microsoft.com/office/drawing/2014/main" id="{306A5864-D34D-4F3E-A7AD-843B4903AA6F}"/>
               </a:ext>
             </a:extLst>
           </p:cNvPr>
@@ -1441,7 +1441,7 @@
           <p:cNvPr id="9" name="1-Method in one line-title">
             <a:extLst xmlns:a="http://schemas.openxmlformats.org/drawingml/2006/main">
               <a:ext uri="{FF2B5EF4-FFF2-40B4-BE49-F238E27FC236}">
-                <a16:creationId xmlns:a16="http://schemas.microsoft.com/office/drawing/2014/main" id="{D74270D0-BF45-401C-A496-86B03929FEC6}"/>
+                <a16:creationId xmlns:a16="http://schemas.microsoft.com/office/drawing/2014/main" id="{441699A9-E1BE-4B15-9138-052CA1EA2E92}"/>
               </a:ext>
             </a:extLst>
           </p:cNvPr>
@@ -1491,7 +1491,7 @@
           <p:cNvPr id="10" name="1-Method in one line-body">
             <a:extLst xmlns:a="http://schemas.openxmlformats.org/drawingml/2006/main">
               <a:ext uri="{FF2B5EF4-FFF2-40B4-BE49-F238E27FC236}">
-                <a16:creationId xmlns:a16="http://schemas.microsoft.com/office/drawing/2014/main" id="{FBE7A65A-E1FE-48DD-8B8E-78ECA91C1211}"/>
+                <a16:creationId xmlns:a16="http://schemas.microsoft.com/office/drawing/2014/main" id="{2A8B129F-7F93-453A-9F21-530F1004170E}"/>
               </a:ext>
             </a:extLst>
           </p:cNvPr>
@@ -1592,7 +1592,7 @@
           <p:cNvPr id="11" name="morrison-formula-box">
             <a:extLst xmlns:a="http://schemas.openxmlformats.org/drawingml/2006/main">
               <a:ext uri="{FF2B5EF4-FFF2-40B4-BE49-F238E27FC236}">
-                <a16:creationId xmlns:a16="http://schemas.microsoft.com/office/drawing/2014/main" id="{F02AF21C-8241-44C5-8095-0374F8834E34}"/>
+                <a16:creationId xmlns:a16="http://schemas.microsoft.com/office/drawing/2014/main" id="{02E84914-16D9-4E09-A16A-5E23E4A169B4}"/>
               </a:ext>
             </a:extLst>
           </p:cNvPr>
@@ -1625,7 +1625,7 @@
           <p:cNvPr id="12" name="morrison-formula-title">
             <a:extLst xmlns:a="http://schemas.openxmlformats.org/drawingml/2006/main">
               <a:ext uri="{FF2B5EF4-FFF2-40B4-BE49-F238E27FC236}">
-                <a16:creationId xmlns:a16="http://schemas.microsoft.com/office/drawing/2014/main" id="{75C011E8-74A7-4650-BB65-3988AD49C63C}"/>
+                <a16:creationId xmlns:a16="http://schemas.microsoft.com/office/drawing/2014/main" id="{A32E9AED-7930-41A4-A477-2C4D9200B1EF}"/>
               </a:ext>
             </a:extLst>
           </p:cNvPr>
@@ -1675,7 +1675,7 @@
           <p:cNvPr id="13" name="morrison-formula">
             <a:extLst xmlns:a="http://schemas.openxmlformats.org/drawingml/2006/main">
               <a:ext uri="{FF2B5EF4-FFF2-40B4-BE49-F238E27FC236}">
-                <a16:creationId xmlns:a16="http://schemas.microsoft.com/office/drawing/2014/main" id="{977D5E72-E325-4976-84F2-21A0D7D0B952}"/>
+                <a16:creationId xmlns:a16="http://schemas.microsoft.com/office/drawing/2014/main" id="{F84B2327-0749-4A89-A188-CAE32143CFC2}"/>
               </a:ext>
             </a:extLst>
           </p:cNvPr>
@@ -1793,7 +1793,7 @@
           <p:cNvPr id="14" name="2-Data and denominators-box">
             <a:extLst xmlns:a="http://schemas.openxmlformats.org/drawingml/2006/main">
               <a:ext uri="{FF2B5EF4-FFF2-40B4-BE49-F238E27FC236}">
-                <a16:creationId xmlns:a16="http://schemas.microsoft.com/office/drawing/2014/main" id="{CA2AC51D-24B8-483D-B848-4D63543A11E4}"/>
+                <a16:creationId xmlns:a16="http://schemas.microsoft.com/office/drawing/2014/main" id="{579C9E39-964B-4CF5-9E10-30DB00B4F822}"/>
               </a:ext>
             </a:extLst>
           </p:cNvPr>
@@ -1826,7 +1826,7 @@
           <p:cNvPr id="15" name="2-Data and denominators-head">
             <a:extLst xmlns:a="http://schemas.openxmlformats.org/drawingml/2006/main">
               <a:ext uri="{FF2B5EF4-FFF2-40B4-BE49-F238E27FC236}">
-                <a16:creationId xmlns:a16="http://schemas.microsoft.com/office/drawing/2014/main" id="{363368C9-43A9-4783-8A3D-D7803E85622D}"/>
+                <a16:creationId xmlns:a16="http://schemas.microsoft.com/office/drawing/2014/main" id="{9D1F4150-1981-4679-9F5F-381C925B27F7}"/>
               </a:ext>
             </a:extLst>
           </p:cNvPr>
@@ -1859,7 +1859,7 @@
           <p:cNvPr id="16" name="2-Data and denominators-title">
             <a:extLst xmlns:a="http://schemas.openxmlformats.org/drawingml/2006/main">
               <a:ext uri="{FF2B5EF4-FFF2-40B4-BE49-F238E27FC236}">
-                <a16:creationId xmlns:a16="http://schemas.microsoft.com/office/drawing/2014/main" id="{48D928BA-1C98-41C2-873A-E5B294C10650}"/>
+                <a16:creationId xmlns:a16="http://schemas.microsoft.com/office/drawing/2014/main" id="{CE9A419B-3580-4573-A169-277F0E9698F5}"/>
               </a:ext>
             </a:extLst>
           </p:cNvPr>
@@ -1909,7 +1909,7 @@
           <p:cNvPr id="17" name="2-Data and denominators-body">
             <a:extLst xmlns:a="http://schemas.openxmlformats.org/drawingml/2006/main">
               <a:ext uri="{FF2B5EF4-FFF2-40B4-BE49-F238E27FC236}">
-                <a16:creationId xmlns:a16="http://schemas.microsoft.com/office/drawing/2014/main" id="{80E4215E-E828-44AC-8742-CF906157B79B}"/>
+                <a16:creationId xmlns:a16="http://schemas.microsoft.com/office/drawing/2014/main" id="{4DD2DBBE-4BFA-4B13-A8C0-7B1914EE99A9}"/>
               </a:ext>
             </a:extLst>
           </p:cNvPr>
@@ -1993,7 +1993,7 @@
           <p:cNvPr id="18" name="3-Why beta CIs?-box">
             <a:extLst xmlns:a="http://schemas.openxmlformats.org/drawingml/2006/main">
               <a:ext uri="{FF2B5EF4-FFF2-40B4-BE49-F238E27FC236}">
-                <a16:creationId xmlns:a16="http://schemas.microsoft.com/office/drawing/2014/main" id="{B37FEAC3-9EDE-47BA-9078-8CCA106702B3}"/>
+                <a16:creationId xmlns:a16="http://schemas.microsoft.com/office/drawing/2014/main" id="{81397162-AB87-42E2-80A5-2C76517A6837}"/>
               </a:ext>
             </a:extLst>
           </p:cNvPr>
@@ -2026,7 +2026,7 @@
           <p:cNvPr id="19" name="3-Why beta CIs?-head">
             <a:extLst xmlns:a="http://schemas.openxmlformats.org/drawingml/2006/main">
               <a:ext uri="{FF2B5EF4-FFF2-40B4-BE49-F238E27FC236}">
-                <a16:creationId xmlns:a16="http://schemas.microsoft.com/office/drawing/2014/main" id="{B41F5C66-8637-4037-9DF4-ADA06D4E1E09}"/>
+                <a16:creationId xmlns:a16="http://schemas.microsoft.com/office/drawing/2014/main" id="{5F079014-5C9E-4CD1-9F57-06B0FFF4D66E}"/>
               </a:ext>
             </a:extLst>
           </p:cNvPr>
@@ -2059,7 +2059,7 @@
           <p:cNvPr id="20" name="3-Why beta CIs?-title">
             <a:extLst xmlns:a="http://schemas.openxmlformats.org/drawingml/2006/main">
               <a:ext uri="{FF2B5EF4-FFF2-40B4-BE49-F238E27FC236}">
-                <a16:creationId xmlns:a16="http://schemas.microsoft.com/office/drawing/2014/main" id="{B9920D36-5EB0-4055-9F64-B7362A791D38}"/>
+                <a16:creationId xmlns:a16="http://schemas.microsoft.com/office/drawing/2014/main" id="{EA1F153F-399E-4043-85AB-C7C11502A03B}"/>
               </a:ext>
             </a:extLst>
           </p:cNvPr>
@@ -2109,7 +2109,7 @@
           <p:cNvPr id="21" name="3-Why beta CIs?-body">
             <a:extLst xmlns:a="http://schemas.openxmlformats.org/drawingml/2006/main">
               <a:ext uri="{FF2B5EF4-FFF2-40B4-BE49-F238E27FC236}">
-                <a16:creationId xmlns:a16="http://schemas.microsoft.com/office/drawing/2014/main" id="{28469837-1877-4D5F-A3F9-5A39EEC9D00D}"/>
+                <a16:creationId xmlns:a16="http://schemas.microsoft.com/office/drawing/2014/main" id="{886F9400-B1A8-4C70-A74E-2CE58923427E}"/>
               </a:ext>
             </a:extLst>
           </p:cNvPr>
@@ -2193,7 +2193,7 @@
           <p:cNvPr id="22" name="4-ETL and interoperability-box">
             <a:extLst xmlns:a="http://schemas.openxmlformats.org/drawingml/2006/main">
               <a:ext uri="{FF2B5EF4-FFF2-40B4-BE49-F238E27FC236}">
-                <a16:creationId xmlns:a16="http://schemas.microsoft.com/office/drawing/2014/main" id="{209A17EA-DD67-4577-8D9D-67DDA120033C}"/>
+                <a16:creationId xmlns:a16="http://schemas.microsoft.com/office/drawing/2014/main" id="{6C15C9A4-0FC0-4F0B-B888-79D9C36E40E7}"/>
               </a:ext>
             </a:extLst>
           </p:cNvPr>
@@ -2226,7 +2226,7 @@
           <p:cNvPr id="23" name="4-ETL and interoperability-head">
             <a:extLst xmlns:a="http://schemas.openxmlformats.org/drawingml/2006/main">
               <a:ext uri="{FF2B5EF4-FFF2-40B4-BE49-F238E27FC236}">
-                <a16:creationId xmlns:a16="http://schemas.microsoft.com/office/drawing/2014/main" id="{699E286A-98EB-4B0B-8C79-A6B34B8E9530}"/>
+                <a16:creationId xmlns:a16="http://schemas.microsoft.com/office/drawing/2014/main" id="{72A0C436-CC38-4927-A1F7-65CA88B6CBDE}"/>
               </a:ext>
             </a:extLst>
           </p:cNvPr>
@@ -2259,7 +2259,7 @@
           <p:cNvPr id="24" name="4-ETL and interoperability-title">
             <a:extLst xmlns:a="http://schemas.openxmlformats.org/drawingml/2006/main">
               <a:ext uri="{FF2B5EF4-FFF2-40B4-BE49-F238E27FC236}">
-                <a16:creationId xmlns:a16="http://schemas.microsoft.com/office/drawing/2014/main" id="{8DBA172B-0DF2-4A7D-BDF0-BC1399C53F0F}"/>
+                <a16:creationId xmlns:a16="http://schemas.microsoft.com/office/drawing/2014/main" id="{6DB66DD0-731B-47A8-BBCD-63C22D13E169}"/>
               </a:ext>
             </a:extLst>
           </p:cNvPr>
@@ -2309,7 +2309,7 @@
           <p:cNvPr id="25" name="4-ETL and interoperability-body">
             <a:extLst xmlns:a="http://schemas.openxmlformats.org/drawingml/2006/main">
               <a:ext uri="{FF2B5EF4-FFF2-40B4-BE49-F238E27FC236}">
-                <a16:creationId xmlns:a16="http://schemas.microsoft.com/office/drawing/2014/main" id="{AB78CB38-17AE-4027-A278-AB3C9ECE893C}"/>
+                <a16:creationId xmlns:a16="http://schemas.microsoft.com/office/drawing/2014/main" id="{19E81CA4-33B8-41BC-B388-DAB8C71C3AFA}"/>
               </a:ext>
             </a:extLst>
           </p:cNvPr>
@@ -2393,7 +2393,7 @@
           <p:cNvPr id="26" name="m-prev-metric">
             <a:extLst xmlns:a="http://schemas.openxmlformats.org/drawingml/2006/main">
               <a:ext uri="{FF2B5EF4-FFF2-40B4-BE49-F238E27FC236}">
-                <a16:creationId xmlns:a16="http://schemas.microsoft.com/office/drawing/2014/main" id="{A60801E9-7843-41A1-9B49-2C85EEBA2212}"/>
+                <a16:creationId xmlns:a16="http://schemas.microsoft.com/office/drawing/2014/main" id="{19418887-6E00-4DC5-AF6D-CECF522BA69E}"/>
               </a:ext>
             </a:extLst>
           </p:cNvPr>
@@ -2426,7 +2426,7 @@
           <p:cNvPr id="27" name="m-prev-metric-title">
             <a:extLst xmlns:a="http://schemas.openxmlformats.org/drawingml/2006/main">
               <a:ext uri="{FF2B5EF4-FFF2-40B4-BE49-F238E27FC236}">
-                <a16:creationId xmlns:a16="http://schemas.microsoft.com/office/drawing/2014/main" id="{FDDD986D-7282-40F9-BDB7-C0A382FAD397}"/>
+                <a16:creationId xmlns:a16="http://schemas.microsoft.com/office/drawing/2014/main" id="{4C9EB2CD-03EE-4B42-B4D8-33BB952D23DD}"/>
               </a:ext>
             </a:extLst>
           </p:cNvPr>
@@ -2476,7 +2476,7 @@
           <p:cNvPr id="28" name="m-prev-metric-value">
             <a:extLst xmlns:a="http://schemas.openxmlformats.org/drawingml/2006/main">
               <a:ext uri="{FF2B5EF4-FFF2-40B4-BE49-F238E27FC236}">
-                <a16:creationId xmlns:a16="http://schemas.microsoft.com/office/drawing/2014/main" id="{4851CDF8-13C0-471D-8136-B7F709E106CD}"/>
+                <a16:creationId xmlns:a16="http://schemas.microsoft.com/office/drawing/2014/main" id="{3B1A7F83-7848-4E52-B074-1E7F8A6FDE98}"/>
               </a:ext>
             </a:extLst>
           </p:cNvPr>
@@ -2526,7 +2526,7 @@
           <p:cNvPr id="29" name="m-prev-metric-note">
             <a:extLst xmlns:a="http://schemas.openxmlformats.org/drawingml/2006/main">
               <a:ext uri="{FF2B5EF4-FFF2-40B4-BE49-F238E27FC236}">
-                <a16:creationId xmlns:a16="http://schemas.microsoft.com/office/drawing/2014/main" id="{B919D514-B959-44CE-ADA8-69970F9B42DA}"/>
+                <a16:creationId xmlns:a16="http://schemas.microsoft.com/office/drawing/2014/main" id="{39C1162C-EA0D-4D15-BF06-2EBFCAA3017A}"/>
               </a:ext>
             </a:extLst>
           </p:cNvPr>
@@ -2576,7 +2576,7 @@
           <p:cNvPr id="30" name="m-crisis-metric">
             <a:extLst xmlns:a="http://schemas.openxmlformats.org/drawingml/2006/main">
               <a:ext uri="{FF2B5EF4-FFF2-40B4-BE49-F238E27FC236}">
-                <a16:creationId xmlns:a16="http://schemas.microsoft.com/office/drawing/2014/main" id="{73D9EBE3-747B-4826-B661-B5BD9D5EA6EB}"/>
+                <a16:creationId xmlns:a16="http://schemas.microsoft.com/office/drawing/2014/main" id="{0CAC820D-B22E-42B0-B204-0062F3482AAE}"/>
               </a:ext>
             </a:extLst>
           </p:cNvPr>
@@ -2609,7 +2609,7 @@
           <p:cNvPr id="31" name="m-crisis-metric-title">
             <a:extLst xmlns:a="http://schemas.openxmlformats.org/drawingml/2006/main">
               <a:ext uri="{FF2B5EF4-FFF2-40B4-BE49-F238E27FC236}">
-                <a16:creationId xmlns:a16="http://schemas.microsoft.com/office/drawing/2014/main" id="{17105B93-0FC9-4C3D-B6AF-78EC13EA48D0}"/>
+                <a16:creationId xmlns:a16="http://schemas.microsoft.com/office/drawing/2014/main" id="{DD18DEA2-FC70-4A94-BEC6-9F5B0B8DC4EA}"/>
               </a:ext>
             </a:extLst>
           </p:cNvPr>
@@ -2659,7 +2659,7 @@
           <p:cNvPr id="32" name="m-crisis-metric-value">
             <a:extLst xmlns:a="http://schemas.openxmlformats.org/drawingml/2006/main">
               <a:ext uri="{FF2B5EF4-FFF2-40B4-BE49-F238E27FC236}">
-                <a16:creationId xmlns:a16="http://schemas.microsoft.com/office/drawing/2014/main" id="{576C704F-34F5-4215-A8B6-97A5933B1110}"/>
+                <a16:creationId xmlns:a16="http://schemas.microsoft.com/office/drawing/2014/main" id="{7B1AC243-C68D-4F79-B487-A16283C32AE1}"/>
               </a:ext>
             </a:extLst>
           </p:cNvPr>
@@ -2709,7 +2709,7 @@
           <p:cNvPr id="33" name="m-crisis-metric-note">
             <a:extLst xmlns:a="http://schemas.openxmlformats.org/drawingml/2006/main">
               <a:ext uri="{FF2B5EF4-FFF2-40B4-BE49-F238E27FC236}">
-                <a16:creationId xmlns:a16="http://schemas.microsoft.com/office/drawing/2014/main" id="{C57F4AA5-8623-4F0C-85A8-4282D1842957}"/>
+                <a16:creationId xmlns:a16="http://schemas.microsoft.com/office/drawing/2014/main" id="{42DECB49-3C0E-419D-A07B-5051A287EA4C}"/>
               </a:ext>
             </a:extLst>
           </p:cNvPr>
@@ -2759,7 +2759,7 @@
           <p:cNvPr id="34" name="m-meds-metric">
             <a:extLst xmlns:a="http://schemas.openxmlformats.org/drawingml/2006/main">
               <a:ext uri="{FF2B5EF4-FFF2-40B4-BE49-F238E27FC236}">
-                <a16:creationId xmlns:a16="http://schemas.microsoft.com/office/drawing/2014/main" id="{14212630-D217-4340-8F25-F67F697068E0}"/>
+                <a16:creationId xmlns:a16="http://schemas.microsoft.com/office/drawing/2014/main" id="{6508A0B7-DD24-4E33-9A60-A99A32177C94}"/>
               </a:ext>
             </a:extLst>
           </p:cNvPr>
@@ -2792,7 +2792,7 @@
           <p:cNvPr id="35" name="m-meds-metric-title">
             <a:extLst xmlns:a="http://schemas.openxmlformats.org/drawingml/2006/main">
               <a:ext uri="{FF2B5EF4-FFF2-40B4-BE49-F238E27FC236}">
-                <a16:creationId xmlns:a16="http://schemas.microsoft.com/office/drawing/2014/main" id="{973D47FA-A8B6-4F9E-BEF5-4AD696E6C35E}"/>
+                <a16:creationId xmlns:a16="http://schemas.microsoft.com/office/drawing/2014/main" id="{D875C4CD-7936-48B8-97D2-B4FA79E13130}"/>
               </a:ext>
             </a:extLst>
           </p:cNvPr>
@@ -2842,7 +2842,7 @@
           <p:cNvPr id="36" name="m-meds-metric-value">
             <a:extLst xmlns:a="http://schemas.openxmlformats.org/drawingml/2006/main">
               <a:ext uri="{FF2B5EF4-FFF2-40B4-BE49-F238E27FC236}">
-                <a16:creationId xmlns:a16="http://schemas.microsoft.com/office/drawing/2014/main" id="{0568B7B3-D492-42C2-BAF4-AD7C5925CC9C}"/>
+                <a16:creationId xmlns:a16="http://schemas.microsoft.com/office/drawing/2014/main" id="{FD066432-AD49-408A-BBDD-45DF5BD2A22B}"/>
               </a:ext>
             </a:extLst>
           </p:cNvPr>
@@ -2892,7 +2892,7 @@
           <p:cNvPr id="37" name="m-meds-metric-note">
             <a:extLst xmlns:a="http://schemas.openxmlformats.org/drawingml/2006/main">
               <a:ext uri="{FF2B5EF4-FFF2-40B4-BE49-F238E27FC236}">
-                <a16:creationId xmlns:a16="http://schemas.microsoft.com/office/drawing/2014/main" id="{1217FDF6-3758-4C82-BFE0-D96462AE5AE5}"/>
+                <a16:creationId xmlns:a16="http://schemas.microsoft.com/office/drawing/2014/main" id="{E0AA9C00-923C-4433-A025-EBDA14948AB3}"/>
               </a:ext>
             </a:extLst>
           </p:cNvPr>
@@ -2942,7 +2942,7 @@
           <p:cNvPr id="38" name="m-chart-prev-caption">
             <a:extLst xmlns:a="http://schemas.openxmlformats.org/drawingml/2006/main">
               <a:ext uri="{FF2B5EF4-FFF2-40B4-BE49-F238E27FC236}">
-                <a16:creationId xmlns:a16="http://schemas.microsoft.com/office/drawing/2014/main" id="{C5A9D9E8-C532-468C-A565-F1FA1B3A4D7E}"/>
+                <a16:creationId xmlns:a16="http://schemas.microsoft.com/office/drawing/2014/main" id="{078FAEE1-21F7-4416-BCBE-C3C84F9B7E7E}"/>
               </a:ext>
             </a:extLst>
           </p:cNvPr>
@@ -2992,7 +2992,7 @@
           <p:cNvPr id="39" name="m-chart-prev-frame">
             <a:extLst xmlns:a="http://schemas.openxmlformats.org/drawingml/2006/main">
               <a:ext uri="{FF2B5EF4-FFF2-40B4-BE49-F238E27FC236}">
-                <a16:creationId xmlns:a16="http://schemas.microsoft.com/office/drawing/2014/main" id="{B60C6F91-BF22-40B6-AA73-72C16E44B81D}"/>
+                <a16:creationId xmlns:a16="http://schemas.microsoft.com/office/drawing/2014/main" id="{D831F4D4-6189-4F24-8FD6-77E6EBBE70DE}"/>
               </a:ext>
             </a:extLst>
           </p:cNvPr>
@@ -3022,14 +3022,14 @@
       </p:sp>
       <p:pic>
         <p:nvPicPr>
-          <p:cNvPr id="103" name=""/>
+          <p:cNvPr id="104" name=""/>
           <p:cNvPicPr>
             <a:picLocks xmlns:a="http://schemas.openxmlformats.org/drawingml/2006/main" noChangeAspect="1"/>
           </p:cNvPicPr>
           <p:nvPr/>
         </p:nvPicPr>
         <p:blipFill>
-          <a:blip xmlns:r="http://schemas.openxmlformats.org/officeDocument/2006/relationships" xmlns:a="http://schemas.openxmlformats.org/drawingml/2006/main" r:embed="R03b06f23e692415c"/>
+          <a:blip xmlns:r="http://schemas.openxmlformats.org/officeDocument/2006/relationships" xmlns:a="http://schemas.openxmlformats.org/drawingml/2006/main" r:embed="Raf9be7e708f94b94"/>
           <a:stretch xmlns:a="http://schemas.openxmlformats.org/drawingml/2006/main"/>
         </p:blipFill>
         <p:spPr>
@@ -3047,7 +3047,7 @@
           <p:cNvPr id="41" name="m-chart-meds-caption">
             <a:extLst xmlns:a="http://schemas.openxmlformats.org/drawingml/2006/main">
               <a:ext uri="{FF2B5EF4-FFF2-40B4-BE49-F238E27FC236}">
-                <a16:creationId xmlns:a16="http://schemas.microsoft.com/office/drawing/2014/main" id="{5D82DAAA-5616-4CDD-9B22-FC15BD1EF45E}"/>
+                <a16:creationId xmlns:a16="http://schemas.microsoft.com/office/drawing/2014/main" id="{154855AF-2E0A-4633-9AE6-825357B850E5}"/>
               </a:ext>
             </a:extLst>
           </p:cNvPr>
@@ -3097,7 +3097,7 @@
           <p:cNvPr id="42" name="m-chart-meds-frame">
             <a:extLst xmlns:a="http://schemas.openxmlformats.org/drawingml/2006/main">
               <a:ext uri="{FF2B5EF4-FFF2-40B4-BE49-F238E27FC236}">
-                <a16:creationId xmlns:a16="http://schemas.microsoft.com/office/drawing/2014/main" id="{D51493F3-6BBC-4414-B200-131944E544C8}"/>
+                <a16:creationId xmlns:a16="http://schemas.microsoft.com/office/drawing/2014/main" id="{1613E63B-AECC-4D56-81DF-D2BC8E0A000E}"/>
               </a:ext>
             </a:extLst>
           </p:cNvPr>
@@ -3127,14 +3127,14 @@
       </p:sp>
       <p:pic>
         <p:nvPicPr>
-          <p:cNvPr id="106" name=""/>
+          <p:cNvPr id="107" name=""/>
           <p:cNvPicPr>
             <a:picLocks xmlns:a="http://schemas.openxmlformats.org/drawingml/2006/main" noChangeAspect="1"/>
           </p:cNvPicPr>
           <p:nvPr/>
         </p:nvPicPr>
         <p:blipFill>
-          <a:blip xmlns:r="http://schemas.openxmlformats.org/officeDocument/2006/relationships" xmlns:a="http://schemas.openxmlformats.org/drawingml/2006/main" r:embed="R5023f48603e04910"/>
+          <a:blip xmlns:r="http://schemas.openxmlformats.org/officeDocument/2006/relationships" xmlns:a="http://schemas.openxmlformats.org/drawingml/2006/main" r:embed="R828062c8adea47db"/>
           <a:stretch xmlns:a="http://schemas.openxmlformats.org/drawingml/2006/main"/>
         </p:blipFill>
         <p:spPr>
@@ -3152,7 +3152,7 @@
           <p:cNvPr id="44" name="m-chart-smoke-caption">
             <a:extLst xmlns:a="http://schemas.openxmlformats.org/drawingml/2006/main">
               <a:ext uri="{FF2B5EF4-FFF2-40B4-BE49-F238E27FC236}">
-                <a16:creationId xmlns:a16="http://schemas.microsoft.com/office/drawing/2014/main" id="{11A000DB-9E1D-4FBD-9F71-8FD3CF611C81}"/>
+                <a16:creationId xmlns:a16="http://schemas.microsoft.com/office/drawing/2014/main" id="{B670413F-8EBB-40F2-A86A-C6A0855BE7EA}"/>
               </a:ext>
             </a:extLst>
           </p:cNvPr>
@@ -3202,7 +3202,7 @@
           <p:cNvPr id="45" name="m-chart-smoke-frame">
             <a:extLst xmlns:a="http://schemas.openxmlformats.org/drawingml/2006/main">
               <a:ext uri="{FF2B5EF4-FFF2-40B4-BE49-F238E27FC236}">
-                <a16:creationId xmlns:a16="http://schemas.microsoft.com/office/drawing/2014/main" id="{F516699F-3593-4673-9239-25D5E86DA0AC}"/>
+                <a16:creationId xmlns:a16="http://schemas.microsoft.com/office/drawing/2014/main" id="{3A6BC5B3-75D3-4D97-A625-1B1429B7E413}"/>
               </a:ext>
             </a:extLst>
           </p:cNvPr>
@@ -3232,14 +3232,14 @@
       </p:sp>
       <p:pic>
         <p:nvPicPr>
-          <p:cNvPr id="109" name=""/>
+          <p:cNvPr id="110" name=""/>
           <p:cNvPicPr>
             <a:picLocks xmlns:a="http://schemas.openxmlformats.org/drawingml/2006/main" noChangeAspect="1"/>
           </p:cNvPicPr>
           <p:nvPr/>
         </p:nvPicPr>
         <p:blipFill>
-          <a:blip xmlns:r="http://schemas.openxmlformats.org/officeDocument/2006/relationships" xmlns:a="http://schemas.openxmlformats.org/drawingml/2006/main" r:embed="Ra2d18521674749aa"/>
+          <a:blip xmlns:r="http://schemas.openxmlformats.org/officeDocument/2006/relationships" xmlns:a="http://schemas.openxmlformats.org/drawingml/2006/main" r:embed="R4f738cbadf1d4ac5"/>
           <a:stretch xmlns:a="http://schemas.openxmlformats.org/drawingml/2006/main"/>
         </p:blipFill>
         <p:spPr>
@@ -3257,7 +3257,7 @@
           <p:cNvPr id="47" name="5-Discussion-box">
             <a:extLst xmlns:a="http://schemas.openxmlformats.org/drawingml/2006/main">
               <a:ext uri="{FF2B5EF4-FFF2-40B4-BE49-F238E27FC236}">
-                <a16:creationId xmlns:a16="http://schemas.microsoft.com/office/drawing/2014/main" id="{5062F57C-DFB4-452D-946C-18A70698A7DB}"/>
+                <a16:creationId xmlns:a16="http://schemas.microsoft.com/office/drawing/2014/main" id="{279DD782-CC00-42F2-A69A-CCC1DEA9B9BF}"/>
               </a:ext>
             </a:extLst>
           </p:cNvPr>
@@ -3290,7 +3290,7 @@
           <p:cNvPr id="48" name="5-Discussion-head">
             <a:extLst xmlns:a="http://schemas.openxmlformats.org/drawingml/2006/main">
               <a:ext uri="{FF2B5EF4-FFF2-40B4-BE49-F238E27FC236}">
-                <a16:creationId xmlns:a16="http://schemas.microsoft.com/office/drawing/2014/main" id="{98FC0017-3B80-4C46-9C0A-35498FEBB974}"/>
+                <a16:creationId xmlns:a16="http://schemas.microsoft.com/office/drawing/2014/main" id="{EC62A2EC-8F23-446E-A94D-39C57AEEA9B7}"/>
               </a:ext>
             </a:extLst>
           </p:cNvPr>
@@ -3323,7 +3323,7 @@
           <p:cNvPr id="49" name="5-Discussion-title">
             <a:extLst xmlns:a="http://schemas.openxmlformats.org/drawingml/2006/main">
               <a:ext uri="{FF2B5EF4-FFF2-40B4-BE49-F238E27FC236}">
-                <a16:creationId xmlns:a16="http://schemas.microsoft.com/office/drawing/2014/main" id="{AFFD0BD6-2B6E-441D-983A-E8C701B5E20D}"/>
+                <a16:creationId xmlns:a16="http://schemas.microsoft.com/office/drawing/2014/main" id="{D3217D52-F1DD-4E9C-8803-08D0F1AE730E}"/>
               </a:ext>
             </a:extLst>
           </p:cNvPr>
@@ -3373,7 +3373,7 @@
           <p:cNvPr id="50" name="5-Discussion-body">
             <a:extLst xmlns:a="http://schemas.openxmlformats.org/drawingml/2006/main">
               <a:ext uri="{FF2B5EF4-FFF2-40B4-BE49-F238E27FC236}">
-                <a16:creationId xmlns:a16="http://schemas.microsoft.com/office/drawing/2014/main" id="{06C5DEFF-D299-4555-8AC0-C2F6B2029A2A}"/>
+                <a16:creationId xmlns:a16="http://schemas.microsoft.com/office/drawing/2014/main" id="{40F3F5A8-2246-4BC8-9652-C901BEE89778}"/>
               </a:ext>
             </a:extLst>
           </p:cNvPr>
@@ -3525,7 +3525,7 @@
           <p:cNvPr id="51" name="6-Central conclusion-box">
             <a:extLst xmlns:a="http://schemas.openxmlformats.org/drawingml/2006/main">
               <a:ext uri="{FF2B5EF4-FFF2-40B4-BE49-F238E27FC236}">
-                <a16:creationId xmlns:a16="http://schemas.microsoft.com/office/drawing/2014/main" id="{6D976B1A-ED83-4AA9-88F8-C57187EA9018}"/>
+                <a16:creationId xmlns:a16="http://schemas.microsoft.com/office/drawing/2014/main" id="{8064B8CC-D2FD-4F38-8516-22C704A3B7CE}"/>
               </a:ext>
             </a:extLst>
           </p:cNvPr>
@@ -3558,7 +3558,7 @@
           <p:cNvPr id="52" name="6-Central conclusion-head">
             <a:extLst xmlns:a="http://schemas.openxmlformats.org/drawingml/2006/main">
               <a:ext uri="{FF2B5EF4-FFF2-40B4-BE49-F238E27FC236}">
-                <a16:creationId xmlns:a16="http://schemas.microsoft.com/office/drawing/2014/main" id="{E6E70CF2-C5CA-453D-8CCF-FA5C7D52D9EC}"/>
+                <a16:creationId xmlns:a16="http://schemas.microsoft.com/office/drawing/2014/main" id="{C0580B82-5B59-4B7B-B101-7B700AA96399}"/>
               </a:ext>
             </a:extLst>
           </p:cNvPr>
@@ -3591,7 +3591,7 @@
           <p:cNvPr id="53" name="6-Central conclusion-title">
             <a:extLst xmlns:a="http://schemas.openxmlformats.org/drawingml/2006/main">
               <a:ext uri="{FF2B5EF4-FFF2-40B4-BE49-F238E27FC236}">
-                <a16:creationId xmlns:a16="http://schemas.microsoft.com/office/drawing/2014/main" id="{77A07877-CF4A-486F-98A2-FCF5E1565821}"/>
+                <a16:creationId xmlns:a16="http://schemas.microsoft.com/office/drawing/2014/main" id="{0B09E707-ED2C-4F56-AA2E-2B53802252E1}"/>
               </a:ext>
             </a:extLst>
           </p:cNvPr>
@@ -3641,7 +3641,7 @@
           <p:cNvPr id="54" name="6-Central conclusion-body">
             <a:extLst xmlns:a="http://schemas.openxmlformats.org/drawingml/2006/main">
               <a:ext uri="{FF2B5EF4-FFF2-40B4-BE49-F238E27FC236}">
-                <a16:creationId xmlns:a16="http://schemas.microsoft.com/office/drawing/2014/main" id="{A0628E55-DBA5-409F-B0AC-299A37CAB1D4}"/>
+                <a16:creationId xmlns:a16="http://schemas.microsoft.com/office/drawing/2014/main" id="{78B59DD8-603A-40A3-82FA-62603D069B44}"/>
               </a:ext>
             </a:extLst>
           </p:cNvPr>
@@ -3725,7 +3725,7 @@
           <p:cNvPr id="55" name="m-chart-crisis-caption">
             <a:extLst xmlns:a="http://schemas.openxmlformats.org/drawingml/2006/main">
               <a:ext uri="{FF2B5EF4-FFF2-40B4-BE49-F238E27FC236}">
-                <a16:creationId xmlns:a16="http://schemas.microsoft.com/office/drawing/2014/main" id="{C3C585E2-B1B8-458C-A71E-A76675E9F3D5}"/>
+                <a16:creationId xmlns:a16="http://schemas.microsoft.com/office/drawing/2014/main" id="{48B738B6-120F-4214-B588-E2B392962CA8}"/>
               </a:ext>
             </a:extLst>
           </p:cNvPr>
@@ -3775,7 +3775,7 @@
           <p:cNvPr id="56" name="m-chart-crisis-frame">
             <a:extLst xmlns:a="http://schemas.openxmlformats.org/drawingml/2006/main">
               <a:ext uri="{FF2B5EF4-FFF2-40B4-BE49-F238E27FC236}">
-                <a16:creationId xmlns:a16="http://schemas.microsoft.com/office/drawing/2014/main" id="{55EBBA24-9314-4C28-9F61-CF8C47EA68AF}"/>
+                <a16:creationId xmlns:a16="http://schemas.microsoft.com/office/drawing/2014/main" id="{4E115667-5D00-43FB-82C7-108BFFDC32F8}"/>
               </a:ext>
             </a:extLst>
           </p:cNvPr>
@@ -3805,14 +3805,14 @@
       </p:sp>
       <p:pic>
         <p:nvPicPr>
-          <p:cNvPr id="120" name=""/>
+          <p:cNvPr id="121" name=""/>
           <p:cNvPicPr>
             <a:picLocks xmlns:a="http://schemas.openxmlformats.org/drawingml/2006/main" noChangeAspect="1"/>
           </p:cNvPicPr>
           <p:nvPr/>
         </p:nvPicPr>
         <p:blipFill>
-          <a:blip xmlns:r="http://schemas.openxmlformats.org/officeDocument/2006/relationships" xmlns:a="http://schemas.openxmlformats.org/drawingml/2006/main" r:embed="R303fb0780265450d"/>
+          <a:blip xmlns:r="http://schemas.openxmlformats.org/officeDocument/2006/relationships" xmlns:a="http://schemas.openxmlformats.org/drawingml/2006/main" r:embed="Rf0ec58bd9175458b"/>
           <a:stretch xmlns:a="http://schemas.openxmlformats.org/drawingml/2006/main"/>
         </p:blipFill>
         <p:spPr>
@@ -3830,7 +3830,7 @@
           <p:cNvPr id="58" name="qr-box">
             <a:extLst xmlns:a="http://schemas.openxmlformats.org/drawingml/2006/main">
               <a:ext uri="{FF2B5EF4-FFF2-40B4-BE49-F238E27FC236}">
-                <a16:creationId xmlns:a16="http://schemas.microsoft.com/office/drawing/2014/main" id="{72ED4A2C-4C63-4A50-9988-6BF3A3A5E350}"/>
+                <a16:creationId xmlns:a16="http://schemas.microsoft.com/office/drawing/2014/main" id="{BFC05223-5456-4CBD-ACC8-2DEFB8252737}"/>
               </a:ext>
             </a:extLst>
           </p:cNvPr>
@@ -3860,14 +3860,14 @@
       </p:sp>
       <p:pic>
         <p:nvPicPr>
-          <p:cNvPr id="122" name=""/>
+          <p:cNvPr id="123" name=""/>
           <p:cNvPicPr>
             <a:picLocks xmlns:a="http://schemas.openxmlformats.org/drawingml/2006/main" noChangeAspect="1"/>
           </p:cNvPicPr>
           <p:nvPr/>
         </p:nvPicPr>
         <p:blipFill>
-          <a:blip xmlns:r="http://schemas.openxmlformats.org/officeDocument/2006/relationships" xmlns:a="http://schemas.openxmlformats.org/drawingml/2006/main" r:embed="Reedfa9a9f28e4690"/>
+          <a:blip xmlns:r="http://schemas.openxmlformats.org/officeDocument/2006/relationships" xmlns:a="http://schemas.openxmlformats.org/drawingml/2006/main" r:embed="R75bcb6c6532d4acc"/>
           <a:stretch xmlns:a="http://schemas.openxmlformats.org/drawingml/2006/main"/>
         </p:blipFill>
         <p:spPr>
@@ -3885,7 +3885,7 @@
           <p:cNvPr id="60" name="qr-label">
             <a:extLst xmlns:a="http://schemas.openxmlformats.org/drawingml/2006/main">
               <a:ext uri="{FF2B5EF4-FFF2-40B4-BE49-F238E27FC236}">
-                <a16:creationId xmlns:a16="http://schemas.microsoft.com/office/drawing/2014/main" id="{284B1126-D6B4-4CFD-8FA2-8340F53C51E5}"/>
+                <a16:creationId xmlns:a16="http://schemas.microsoft.com/office/drawing/2014/main" id="{977B54EA-87DB-406A-BE9C-201130A01479}"/>
               </a:ext>
             </a:extLst>
           </p:cNvPr>
@@ -3952,7 +3952,7 @@
           <p:cNvPr id="61" name="references-box">
             <a:extLst xmlns:a="http://schemas.openxmlformats.org/drawingml/2006/main">
               <a:ext uri="{FF2B5EF4-FFF2-40B4-BE49-F238E27FC236}">
-                <a16:creationId xmlns:a16="http://schemas.microsoft.com/office/drawing/2014/main" id="{A1FA98AD-5DE6-4480-BFF2-0BD6C12830C2}"/>
+                <a16:creationId xmlns:a16="http://schemas.microsoft.com/office/drawing/2014/main" id="{5B82C0EB-7D43-4F3A-B51B-6E2E479FCD96}"/>
               </a:ext>
             </a:extLst>
           </p:cNvPr>
@@ -3985,7 +3985,7 @@
           <p:cNvPr id="62" name="references-title">
             <a:extLst xmlns:a="http://schemas.openxmlformats.org/drawingml/2006/main">
               <a:ext uri="{FF2B5EF4-FFF2-40B4-BE49-F238E27FC236}">
-                <a16:creationId xmlns:a16="http://schemas.microsoft.com/office/drawing/2014/main" id="{891BD574-A221-473A-9635-D7E8D22214F3}"/>
+                <a16:creationId xmlns:a16="http://schemas.microsoft.com/office/drawing/2014/main" id="{233B0604-2EBB-4DCE-B750-A3D7499341B4}"/>
               </a:ext>
             </a:extLst>
           </p:cNvPr>
@@ -4032,10 +4032,10 @@
       </p:sp>
       <p:sp>
         <p:nvSpPr>
-          <p:cNvPr id="63" name="references-body">
-            <a:extLst xmlns:a="http://schemas.openxmlformats.org/drawingml/2006/main">
-              <a:ext uri="{FF2B5EF4-FFF2-40B4-BE49-F238E27FC236}">
-                <a16:creationId xmlns:a16="http://schemas.microsoft.com/office/drawing/2014/main" id="{EACE7DC9-D049-4D18-A9F1-79074A0BA49D}"/>
+          <p:cNvPr id="63" name="references-body-left">
+            <a:extLst xmlns:a="http://schemas.openxmlformats.org/drawingml/2006/main">
+              <a:ext uri="{FF2B5EF4-FFF2-40B4-BE49-F238E27FC236}">
+                <a16:creationId xmlns:a16="http://schemas.microsoft.com/office/drawing/2014/main" id="{5B81CCD5-7703-4B69-BFA7-A72F30E9C02F}"/>
               </a:ext>
             </a:extLst>
           </p:cNvPr>
@@ -4047,7 +4047,7 @@
         <p:spPr>
           <a:xfrm xmlns:a="http://schemas.openxmlformats.org/drawingml/2006/main">
             <a:off x="400050" y="12649200"/>
-            <a:ext cx="8724900" cy="533400"/>
+            <a:ext cx="4276725" cy="533400"/>
           </a:xfrm>
           <a:prstGeom xmlns:a="http://schemas.openxmlformats.org/drawingml/2006/main" prst="rect">
             <a:avLst/>
@@ -4063,14 +4063,14 @@
           <a:lstStyle xmlns:a="http://schemas.openxmlformats.org/drawingml/2006/main"/>
           <a:p xmlns:a="http://schemas.openxmlformats.org/drawingml/2006/main">
             <a:pPr algn="l">
-              <a:defRPr sz="338" b="0">
-                <a:solidFill>
-                  <a:srgbClr val="102536"/>
-                </a:solidFill>
-              </a:defRPr>
-            </a:pPr>
-            <a:r>
-              <a:rPr sz="338" b="0">
+              <a:defRPr sz="368" b="0">
+                <a:solidFill>
+                  <a:srgbClr val="102536"/>
+                </a:solidFill>
+              </a:defRPr>
+            </a:pPr>
+            <a:r>
+              <a:rPr sz="368" b="0">
                 <a:solidFill>
                   <a:srgbClr val="102536"/>
                 </a:solidFill>
@@ -4080,14 +4080,14 @@
           </a:p>
           <a:p xmlns:a="http://schemas.openxmlformats.org/drawingml/2006/main">
             <a:pPr algn="l">
-              <a:defRPr sz="338" b="0">
-                <a:solidFill>
-                  <a:srgbClr val="102536"/>
-                </a:solidFill>
-              </a:defRPr>
-            </a:pPr>
-            <a:r>
-              <a:rPr sz="338" b="0">
+              <a:defRPr sz="368" b="0">
+                <a:solidFill>
+                  <a:srgbClr val="102536"/>
+                </a:solidFill>
+              </a:defRPr>
+            </a:pPr>
+            <a:r>
+              <a:rPr sz="368" b="0">
                 <a:solidFill>
                   <a:srgbClr val="102536"/>
                 </a:solidFill>
@@ -4097,14 +4097,14 @@
           </a:p>
           <a:p xmlns:a="http://schemas.openxmlformats.org/drawingml/2006/main">
             <a:pPr algn="l">
-              <a:defRPr sz="338" b="0">
-                <a:solidFill>
-                  <a:srgbClr val="102536"/>
-                </a:solidFill>
-              </a:defRPr>
-            </a:pPr>
-            <a:r>
-              <a:rPr sz="338" b="0">
+              <a:defRPr sz="368" b="0">
+                <a:solidFill>
+                  <a:srgbClr val="102536"/>
+                </a:solidFill>
+              </a:defRPr>
+            </a:pPr>
+            <a:r>
+              <a:rPr sz="368" b="0">
                 <a:solidFill>
                   <a:srgbClr val="102536"/>
                 </a:solidFill>
@@ -4114,14 +4114,14 @@
           </a:p>
           <a:p xmlns:a="http://schemas.openxmlformats.org/drawingml/2006/main">
             <a:pPr algn="l">
-              <a:defRPr sz="338" b="0">
-                <a:solidFill>
-                  <a:srgbClr val="102536"/>
-                </a:solidFill>
-              </a:defRPr>
-            </a:pPr>
-            <a:r>
-              <a:rPr sz="338" b="0">
+              <a:defRPr sz="368" b="0">
+                <a:solidFill>
+                  <a:srgbClr val="102536"/>
+                </a:solidFill>
+              </a:defRPr>
+            </a:pPr>
+            <a:r>
+              <a:rPr sz="368" b="0">
                 <a:solidFill>
                   <a:srgbClr val="102536"/>
                 </a:solidFill>
@@ -4131,14 +4131,14 @@
           </a:p>
           <a:p xmlns:a="http://schemas.openxmlformats.org/drawingml/2006/main">
             <a:pPr algn="l">
-              <a:defRPr sz="338" b="0">
-                <a:solidFill>
-                  <a:srgbClr val="102536"/>
-                </a:solidFill>
-              </a:defRPr>
-            </a:pPr>
-            <a:r>
-              <a:rPr sz="338" b="0">
+              <a:defRPr sz="368" b="0">
+                <a:solidFill>
+                  <a:srgbClr val="102536"/>
+                </a:solidFill>
+              </a:defRPr>
+            </a:pPr>
+            <a:r>
+              <a:rPr sz="368" b="0">
                 <a:solidFill>
                   <a:srgbClr val="102536"/>
                 </a:solidFill>
@@ -4148,14 +4148,14 @@
           </a:p>
           <a:p xmlns:a="http://schemas.openxmlformats.org/drawingml/2006/main">
             <a:pPr algn="l">
-              <a:defRPr sz="338" b="0">
-                <a:solidFill>
-                  <a:srgbClr val="102536"/>
-                </a:solidFill>
-              </a:defRPr>
-            </a:pPr>
-            <a:r>
-              <a:rPr sz="338" b="0">
+              <a:defRPr sz="368" b="0">
+                <a:solidFill>
+                  <a:srgbClr val="102536"/>
+                </a:solidFill>
+              </a:defRPr>
+            </a:pPr>
+            <a:r>
+              <a:rPr sz="368" b="0">
                 <a:solidFill>
                   <a:srgbClr val="102536"/>
                 </a:solidFill>
@@ -4165,14 +4165,14 @@
           </a:p>
           <a:p xmlns:a="http://schemas.openxmlformats.org/drawingml/2006/main">
             <a:pPr algn="l">
-              <a:defRPr sz="338" b="0">
-                <a:solidFill>
-                  <a:srgbClr val="102536"/>
-                </a:solidFill>
-              </a:defRPr>
-            </a:pPr>
-            <a:r>
-              <a:rPr sz="338" b="0">
+              <a:defRPr sz="368" b="0">
+                <a:solidFill>
+                  <a:srgbClr val="102536"/>
+                </a:solidFill>
+              </a:defRPr>
+            </a:pPr>
+            <a:r>
+              <a:rPr sz="368" b="0">
                 <a:solidFill>
                   <a:srgbClr val="102536"/>
                 </a:solidFill>
@@ -4180,16 +4180,49 @@
               <a:t>[7] TO, T. et al. Global asthma prevalence in adults: findings from the cross-sectional world health survey. BMC Public Health, v. 12, art. 204, 2012. doi:10.1186/1471-2458-12-204.</a:t>
             </a:r>
           </a:p>
-          <a:p xmlns:a="http://schemas.openxmlformats.org/drawingml/2006/main">
-            <a:pPr algn="l">
-              <a:defRPr sz="338" b="0">
-                <a:solidFill>
-                  <a:srgbClr val="102536"/>
-                </a:solidFill>
-              </a:defRPr>
-            </a:pPr>
-            <a:r>
-              <a:rPr sz="338" b="0">
+        </p:txBody>
+      </p:sp>
+      <p:sp>
+        <p:nvSpPr>
+          <p:cNvPr id="64" name="references-body-right">
+            <a:extLst xmlns:a="http://schemas.openxmlformats.org/drawingml/2006/main">
+              <a:ext uri="{FF2B5EF4-FFF2-40B4-BE49-F238E27FC236}">
+                <a16:creationId xmlns:a16="http://schemas.microsoft.com/office/drawing/2014/main" id="{617868D5-6225-4B73-A46D-60CABF875A8E}"/>
+              </a:ext>
+            </a:extLst>
+          </p:cNvPr>
+          <p:cNvSpPr>
+            <a:spLocks xmlns:a="http://schemas.openxmlformats.org/drawingml/2006/main" noGrp="1"/>
+          </p:cNvSpPr>
+          <p:nvPr/>
+        </p:nvSpPr>
+        <p:spPr>
+          <a:xfrm xmlns:a="http://schemas.openxmlformats.org/drawingml/2006/main">
+            <a:off x="4848225" y="12649200"/>
+            <a:ext cx="4276725" cy="533400"/>
+          </a:xfrm>
+          <a:prstGeom xmlns:a="http://schemas.openxmlformats.org/drawingml/2006/main" prst="rect">
+            <a:avLst/>
+          </a:prstGeom>
+          <a:noFill xmlns:a="http://schemas.openxmlformats.org/drawingml/2006/main"/>
+          <a:ln xmlns:a="http://schemas.openxmlformats.org/drawingml/2006/main" w="0">
+            <a:noFill/>
+            <a:prstDash val="solid"/>
+          </a:ln>
+        </p:spPr>
+        <p:txBody>
+          <a:bodyPr xmlns:a="http://schemas.openxmlformats.org/drawingml/2006/main"/>
+          <a:lstStyle xmlns:a="http://schemas.openxmlformats.org/drawingml/2006/main"/>
+          <a:p xmlns:a="http://schemas.openxmlformats.org/drawingml/2006/main">
+            <a:pPr algn="l">
+              <a:defRPr sz="368" b="0">
+                <a:solidFill>
+                  <a:srgbClr val="102536"/>
+                </a:solidFill>
+              </a:defRPr>
+            </a:pPr>
+            <a:r>
+              <a:rPr sz="368" b="0">
                 <a:solidFill>
                   <a:srgbClr val="102536"/>
                 </a:solidFill>
@@ -4199,14 +4232,14 @@
           </a:p>
           <a:p xmlns:a="http://schemas.openxmlformats.org/drawingml/2006/main">
             <a:pPr algn="l">
-              <a:defRPr sz="338" b="0">
-                <a:solidFill>
-                  <a:srgbClr val="102536"/>
-                </a:solidFill>
-              </a:defRPr>
-            </a:pPr>
-            <a:r>
-              <a:rPr sz="338" b="0">
+              <a:defRPr sz="368" b="0">
+                <a:solidFill>
+                  <a:srgbClr val="102536"/>
+                </a:solidFill>
+              </a:defRPr>
+            </a:pPr>
+            <a:r>
+              <a:rPr sz="368" b="0">
                 <a:solidFill>
                   <a:srgbClr val="102536"/>
                 </a:solidFill>
@@ -4216,14 +4249,14 @@
           </a:p>
           <a:p xmlns:a="http://schemas.openxmlformats.org/drawingml/2006/main">
             <a:pPr algn="l">
-              <a:defRPr sz="338" b="0">
-                <a:solidFill>
-                  <a:srgbClr val="102536"/>
-                </a:solidFill>
-              </a:defRPr>
-            </a:pPr>
-            <a:r>
-              <a:rPr sz="338" b="0">
+              <a:defRPr sz="368" b="0">
+                <a:solidFill>
+                  <a:srgbClr val="102536"/>
+                </a:solidFill>
+              </a:defRPr>
+            </a:pPr>
+            <a:r>
+              <a:rPr sz="368" b="0">
                 <a:solidFill>
                   <a:srgbClr val="102536"/>
                 </a:solidFill>
@@ -4233,14 +4266,14 @@
           </a:p>
           <a:p xmlns:a="http://schemas.openxmlformats.org/drawingml/2006/main">
             <a:pPr algn="l">
-              <a:defRPr sz="338" b="0">
-                <a:solidFill>
-                  <a:srgbClr val="102536"/>
-                </a:solidFill>
-              </a:defRPr>
-            </a:pPr>
-            <a:r>
-              <a:rPr sz="338" b="0">
+              <a:defRPr sz="368" b="0">
+                <a:solidFill>
+                  <a:srgbClr val="102536"/>
+                </a:solidFill>
+              </a:defRPr>
+            </a:pPr>
+            <a:r>
+              <a:rPr sz="368" b="0">
                 <a:solidFill>
                   <a:srgbClr val="102536"/>
                 </a:solidFill>
@@ -4250,14 +4283,14 @@
           </a:p>
           <a:p xmlns:a="http://schemas.openxmlformats.org/drawingml/2006/main">
             <a:pPr algn="l">
-              <a:defRPr sz="338" b="0">
-                <a:solidFill>
-                  <a:srgbClr val="102536"/>
-                </a:solidFill>
-              </a:defRPr>
-            </a:pPr>
-            <a:r>
-              <a:rPr sz="338" b="0">
+              <a:defRPr sz="368" b="0">
+                <a:solidFill>
+                  <a:srgbClr val="102536"/>
+                </a:solidFill>
+              </a:defRPr>
+            </a:pPr>
+            <a:r>
+              <a:rPr sz="368" b="0">
                 <a:solidFill>
                   <a:srgbClr val="102536"/>
                 </a:solidFill>
@@ -4267,14 +4300,14 @@
           </a:p>
           <a:p xmlns:a="http://schemas.openxmlformats.org/drawingml/2006/main">
             <a:pPr algn="l">
-              <a:defRPr sz="338" b="0">
-                <a:solidFill>
-                  <a:srgbClr val="102536"/>
-                </a:solidFill>
-              </a:defRPr>
-            </a:pPr>
-            <a:r>
-              <a:rPr sz="338" b="0">
+              <a:defRPr sz="368" b="0">
+                <a:solidFill>
+                  <a:srgbClr val="102536"/>
+                </a:solidFill>
+              </a:defRPr>
+            </a:pPr>
+            <a:r>
+              <a:rPr sz="368" b="0">
                 <a:solidFill>
                   <a:srgbClr val="102536"/>
                 </a:solidFill>
@@ -4287,7 +4320,7 @@
     </p:spTree>
     <p:extLst>
       <p:ext uri="{BB962C8B-B14F-4D97-AF65-F5344CB8AC3E}">
-        <p14:creationId xmlns:p14="http://schemas.microsoft.com/office/powerpoint/2010/main" val="1923956554"/>
+        <p14:creationId xmlns:p14="http://schemas.microsoft.com/office/powerpoint/2010/main" val="948577147"/>
       </p:ext>
     </p:extLst>
   </p:cSld>

</xml_diff>

<commit_message>
Make Morrison poster references visibly two-column
</commit_message>
<xml_diff>
--- a/outputs/posters/poster_pns_asma_morrison_en.pptx
+++ b/outputs/posters/poster_pns_asma_morrison_en.pptx
@@ -2,13 +2,13 @@
 <file path=ppt/presentation.xml><?xml version="1.0" encoding="utf-8"?>
 <p:presentation xmlns:p="http://schemas.openxmlformats.org/presentationml/2006/main">
   <p:sldMasterIdLst>
-    <p:sldMasterId xmlns:r="http://schemas.openxmlformats.org/officeDocument/2006/relationships" id="2147483648" r:id="R8ada595fdf254012"/>
+    <p:sldMasterId xmlns:r="http://schemas.openxmlformats.org/officeDocument/2006/relationships" id="2147483648" r:id="Rb796f47f85a94d52"/>
   </p:sldMasterIdLst>
   <p:notesMasterIdLst>
-    <p:notesMasterId xmlns:r="http://schemas.openxmlformats.org/officeDocument/2006/relationships" r:id="Ra3820a20b54d49f1"/>
+    <p:notesMasterId xmlns:r="http://schemas.openxmlformats.org/officeDocument/2006/relationships" r:id="R779ecc9d6f95419a"/>
   </p:notesMasterIdLst>
   <p:sldIdLst>
-    <p:sldId xmlns:r="http://schemas.openxmlformats.org/officeDocument/2006/relationships" id="256" r:id="Rf14fb708bc264b7f"/>
+    <p:sldId xmlns:r="http://schemas.openxmlformats.org/officeDocument/2006/relationships" id="256" r:id="Ree48ac6190a542c7"/>
   </p:sldIdLst>
   <p:sldSz cx="9525000" cy="13468350"/>
   <p:notesSz cx="6858000" cy="9144000"/>
@@ -601,7 +601,7 @@
   </p:cSld>
   <p:clrMap bg1="lt1" tx1="dk1" bg2="lt2" tx2="dk2" accent1="accent1" accent2="accent2" accent3="accent3" accent4="accent4" accent5="accent5" accent6="accent6" hlink="hlink" folHlink="folHlink"/>
   <p:sldLayoutIdLst>
-    <p:sldLayoutId xmlns:r="http://schemas.openxmlformats.org/officeDocument/2006/relationships" id="2147483649" r:id="R23e58f06122d43a5"/>
+    <p:sldLayoutId xmlns:r="http://schemas.openxmlformats.org/officeDocument/2006/relationships" id="2147483649" r:id="Rc551c62876b34c2d"/>
   </p:sldLayoutIdLst>
   <p:txStyles>
     <p:titleStyle>
@@ -1149,14 +1149,14 @@
       </p:grpSpPr>
       <p:pic>
         <p:nvPicPr>
-          <p:cNvPr id="65" name=""/>
+          <p:cNvPr id="66" name=""/>
           <p:cNvPicPr>
             <a:picLocks xmlns:a="http://schemas.openxmlformats.org/drawingml/2006/main" noChangeAspect="1"/>
           </p:cNvPicPr>
           <p:nvPr/>
         </p:nvPicPr>
         <p:blipFill>
-          <a:blip xmlns:r="http://schemas.openxmlformats.org/officeDocument/2006/relationships" xmlns:a="http://schemas.openxmlformats.org/drawingml/2006/main" r:embed="R10fe8035664d4b84"/>
+          <a:blip xmlns:r="http://schemas.openxmlformats.org/officeDocument/2006/relationships" xmlns:a="http://schemas.openxmlformats.org/drawingml/2006/main" r:embed="R6511fded18434444"/>
           <a:srcRect xmlns:a="http://schemas.openxmlformats.org/drawingml/2006/main" l="0" t="38622" r="0" b="38622"/>
           <a:stretch xmlns:a="http://schemas.openxmlformats.org/drawingml/2006/main">
             <a:fillRect l="0" t="0" r="0" b="0"/>
@@ -1166,28 +1166,6 @@
           <a:xfrm xmlns:a="http://schemas.openxmlformats.org/drawingml/2006/main">
             <a:off x="0" y="0"/>
             <a:ext cx="9525000" cy="1219200"/>
-          </a:xfrm>
-          <a:prstGeom xmlns:a="http://schemas.openxmlformats.org/drawingml/2006/main" prst="rect">
-            <a:avLst/>
-          </a:prstGeom>
-        </p:spPr>
-      </p:pic>
-      <p:pic>
-        <p:nvPicPr>
-          <p:cNvPr id="66" name=""/>
-          <p:cNvPicPr>
-            <a:picLocks xmlns:a="http://schemas.openxmlformats.org/drawingml/2006/main" noChangeAspect="1"/>
-          </p:cNvPicPr>
-          <p:nvPr/>
-        </p:nvPicPr>
-        <p:blipFill>
-          <a:blip xmlns:r="http://schemas.openxmlformats.org/officeDocument/2006/relationships" xmlns:a="http://schemas.openxmlformats.org/drawingml/2006/main" r:embed="R5596aa549d6b4f72"/>
-          <a:stretch xmlns:a="http://schemas.openxmlformats.org/drawingml/2006/main"/>
-        </p:blipFill>
-        <p:spPr>
-          <a:xfrm xmlns:a="http://schemas.openxmlformats.org/drawingml/2006/main">
-            <a:off x="323850" y="265374"/>
-            <a:ext cx="2952750" cy="612252"/>
           </a:xfrm>
           <a:prstGeom xmlns:a="http://schemas.openxmlformats.org/drawingml/2006/main" prst="rect">
             <a:avLst/>
@@ -1203,11 +1181,33 @@
           <p:nvPr/>
         </p:nvPicPr>
         <p:blipFill>
-          <a:blip xmlns:r="http://schemas.openxmlformats.org/officeDocument/2006/relationships" xmlns:a="http://schemas.openxmlformats.org/drawingml/2006/main" r:embed="Rd485346d649048b6"/>
+          <a:blip xmlns:r="http://schemas.openxmlformats.org/officeDocument/2006/relationships" xmlns:a="http://schemas.openxmlformats.org/drawingml/2006/main" r:embed="Reff777fb585845d3"/>
           <a:stretch xmlns:a="http://schemas.openxmlformats.org/drawingml/2006/main"/>
         </p:blipFill>
         <p:spPr>
           <a:xfrm xmlns:a="http://schemas.openxmlformats.org/drawingml/2006/main">
+            <a:off x="323850" y="265374"/>
+            <a:ext cx="2952750" cy="612252"/>
+          </a:xfrm>
+          <a:prstGeom xmlns:a="http://schemas.openxmlformats.org/drawingml/2006/main" prst="rect">
+            <a:avLst/>
+          </a:prstGeom>
+        </p:spPr>
+      </p:pic>
+      <p:pic>
+        <p:nvPicPr>
+          <p:cNvPr id="68" name=""/>
+          <p:cNvPicPr>
+            <a:picLocks xmlns:a="http://schemas.openxmlformats.org/drawingml/2006/main" noChangeAspect="1"/>
+          </p:cNvPicPr>
+          <p:nvPr/>
+        </p:nvPicPr>
+        <p:blipFill>
+          <a:blip xmlns:r="http://schemas.openxmlformats.org/officeDocument/2006/relationships" xmlns:a="http://schemas.openxmlformats.org/drawingml/2006/main" r:embed="Ra154fb04bec84f03"/>
+          <a:stretch xmlns:a="http://schemas.openxmlformats.org/drawingml/2006/main"/>
+        </p:blipFill>
+        <p:spPr>
+          <a:xfrm xmlns:a="http://schemas.openxmlformats.org/drawingml/2006/main">
             <a:off x="3905250" y="425056"/>
             <a:ext cx="4953000" cy="311937"/>
           </a:xfrm>
@@ -1221,7 +1221,7 @@
           <p:cNvPr id="4" name="morrison-title">
             <a:extLst xmlns:a="http://schemas.openxmlformats.org/drawingml/2006/main">
               <a:ext uri="{FF2B5EF4-FFF2-40B4-BE49-F238E27FC236}">
-                <a16:creationId xmlns:a16="http://schemas.microsoft.com/office/drawing/2014/main" id="{A37EC5BE-B84C-438D-A717-07894D4F40F1}"/>
+                <a16:creationId xmlns:a16="http://schemas.microsoft.com/office/drawing/2014/main" id="{D5514971-68DA-40B8-8E73-2BE5ED6DC158}"/>
               </a:ext>
             </a:extLst>
           </p:cNvPr>
@@ -1271,7 +1271,7 @@
           <p:cNvPr id="5" name="morrison-authors">
             <a:extLst xmlns:a="http://schemas.openxmlformats.org/drawingml/2006/main">
               <a:ext uri="{FF2B5EF4-FFF2-40B4-BE49-F238E27FC236}">
-                <a16:creationId xmlns:a16="http://schemas.microsoft.com/office/drawing/2014/main" id="{E614DFB2-0F89-4140-927A-1239DE340DFE}"/>
+                <a16:creationId xmlns:a16="http://schemas.microsoft.com/office/drawing/2014/main" id="{55262E77-5F08-48AE-981E-A557DBC92DF0}"/>
               </a:ext>
             </a:extLst>
           </p:cNvPr>
@@ -1321,7 +1321,7 @@
           <p:cNvPr id="6" name="central-message">
             <a:extLst xmlns:a="http://schemas.openxmlformats.org/drawingml/2006/main">
               <a:ext uri="{FF2B5EF4-FFF2-40B4-BE49-F238E27FC236}">
-                <a16:creationId xmlns:a16="http://schemas.microsoft.com/office/drawing/2014/main" id="{19157170-E41D-4E1A-860F-1D59C7CEAF04}"/>
+                <a16:creationId xmlns:a16="http://schemas.microsoft.com/office/drawing/2014/main" id="{E93989B3-CDBF-45D9-A390-061EC124EA2B}"/>
               </a:ext>
             </a:extLst>
           </p:cNvPr>
@@ -1375,7 +1375,7 @@
           <p:cNvPr id="7" name="1-Method in one line-box">
             <a:extLst xmlns:a="http://schemas.openxmlformats.org/drawingml/2006/main">
               <a:ext uri="{FF2B5EF4-FFF2-40B4-BE49-F238E27FC236}">
-                <a16:creationId xmlns:a16="http://schemas.microsoft.com/office/drawing/2014/main" id="{2B1A9B64-A63D-4298-8B22-12B50404BD79}"/>
+                <a16:creationId xmlns:a16="http://schemas.microsoft.com/office/drawing/2014/main" id="{FDC6CA63-1B02-41F4-9C79-2E9A5AC373AC}"/>
               </a:ext>
             </a:extLst>
           </p:cNvPr>
@@ -1408,7 +1408,7 @@
           <p:cNvPr id="8" name="1-Method in one line-head">
             <a:extLst xmlns:a="http://schemas.openxmlformats.org/drawingml/2006/main">
               <a:ext uri="{FF2B5EF4-FFF2-40B4-BE49-F238E27FC236}">
-                <a16:creationId xmlns:a16="http://schemas.microsoft.com/office/drawing/2014/main" id="{306A5864-D34D-4F3E-A7AD-843B4903AA6F}"/>
+                <a16:creationId xmlns:a16="http://schemas.microsoft.com/office/drawing/2014/main" id="{9709E071-D115-4255-9A0E-F7B3378A8AFD}"/>
               </a:ext>
             </a:extLst>
           </p:cNvPr>
@@ -1441,7 +1441,7 @@
           <p:cNvPr id="9" name="1-Method in one line-title">
             <a:extLst xmlns:a="http://schemas.openxmlformats.org/drawingml/2006/main">
               <a:ext uri="{FF2B5EF4-FFF2-40B4-BE49-F238E27FC236}">
-                <a16:creationId xmlns:a16="http://schemas.microsoft.com/office/drawing/2014/main" id="{441699A9-E1BE-4B15-9138-052CA1EA2E92}"/>
+                <a16:creationId xmlns:a16="http://schemas.microsoft.com/office/drawing/2014/main" id="{DB42F00D-00E2-4837-B876-A2A18CC72507}"/>
               </a:ext>
             </a:extLst>
           </p:cNvPr>
@@ -1491,7 +1491,7 @@
           <p:cNvPr id="10" name="1-Method in one line-body">
             <a:extLst xmlns:a="http://schemas.openxmlformats.org/drawingml/2006/main">
               <a:ext uri="{FF2B5EF4-FFF2-40B4-BE49-F238E27FC236}">
-                <a16:creationId xmlns:a16="http://schemas.microsoft.com/office/drawing/2014/main" id="{2A8B129F-7F93-453A-9F21-530F1004170E}"/>
+                <a16:creationId xmlns:a16="http://schemas.microsoft.com/office/drawing/2014/main" id="{6CDBA738-096E-4210-92A6-F9256893659F}"/>
               </a:ext>
             </a:extLst>
           </p:cNvPr>
@@ -1592,7 +1592,7 @@
           <p:cNvPr id="11" name="morrison-formula-box">
             <a:extLst xmlns:a="http://schemas.openxmlformats.org/drawingml/2006/main">
               <a:ext uri="{FF2B5EF4-FFF2-40B4-BE49-F238E27FC236}">
-                <a16:creationId xmlns:a16="http://schemas.microsoft.com/office/drawing/2014/main" id="{02E84914-16D9-4E09-A16A-5E23E4A169B4}"/>
+                <a16:creationId xmlns:a16="http://schemas.microsoft.com/office/drawing/2014/main" id="{3462C64B-05A0-4064-81CD-DFE17BA55489}"/>
               </a:ext>
             </a:extLst>
           </p:cNvPr>
@@ -1625,7 +1625,7 @@
           <p:cNvPr id="12" name="morrison-formula-title">
             <a:extLst xmlns:a="http://schemas.openxmlformats.org/drawingml/2006/main">
               <a:ext uri="{FF2B5EF4-FFF2-40B4-BE49-F238E27FC236}">
-                <a16:creationId xmlns:a16="http://schemas.microsoft.com/office/drawing/2014/main" id="{A32E9AED-7930-41A4-A477-2C4D9200B1EF}"/>
+                <a16:creationId xmlns:a16="http://schemas.microsoft.com/office/drawing/2014/main" id="{D8B918EC-02C2-498A-B82E-EDC14FFA3D69}"/>
               </a:ext>
             </a:extLst>
           </p:cNvPr>
@@ -1675,7 +1675,7 @@
           <p:cNvPr id="13" name="morrison-formula">
             <a:extLst xmlns:a="http://schemas.openxmlformats.org/drawingml/2006/main">
               <a:ext uri="{FF2B5EF4-FFF2-40B4-BE49-F238E27FC236}">
-                <a16:creationId xmlns:a16="http://schemas.microsoft.com/office/drawing/2014/main" id="{F84B2327-0749-4A89-A188-CAE32143CFC2}"/>
+                <a16:creationId xmlns:a16="http://schemas.microsoft.com/office/drawing/2014/main" id="{02C7B5BA-F6DC-469A-BFD5-C2286358A15F}"/>
               </a:ext>
             </a:extLst>
           </p:cNvPr>
@@ -1793,7 +1793,7 @@
           <p:cNvPr id="14" name="2-Data and denominators-box">
             <a:extLst xmlns:a="http://schemas.openxmlformats.org/drawingml/2006/main">
               <a:ext uri="{FF2B5EF4-FFF2-40B4-BE49-F238E27FC236}">
-                <a16:creationId xmlns:a16="http://schemas.microsoft.com/office/drawing/2014/main" id="{579C9E39-964B-4CF5-9E10-30DB00B4F822}"/>
+                <a16:creationId xmlns:a16="http://schemas.microsoft.com/office/drawing/2014/main" id="{483D3862-E2B7-4013-A75A-7F8E9ED61104}"/>
               </a:ext>
             </a:extLst>
           </p:cNvPr>
@@ -1826,7 +1826,7 @@
           <p:cNvPr id="15" name="2-Data and denominators-head">
             <a:extLst xmlns:a="http://schemas.openxmlformats.org/drawingml/2006/main">
               <a:ext uri="{FF2B5EF4-FFF2-40B4-BE49-F238E27FC236}">
-                <a16:creationId xmlns:a16="http://schemas.microsoft.com/office/drawing/2014/main" id="{9D1F4150-1981-4679-9F5F-381C925B27F7}"/>
+                <a16:creationId xmlns:a16="http://schemas.microsoft.com/office/drawing/2014/main" id="{30228466-4B64-4CD1-A465-68A8488C443A}"/>
               </a:ext>
             </a:extLst>
           </p:cNvPr>
@@ -1859,7 +1859,7 @@
           <p:cNvPr id="16" name="2-Data and denominators-title">
             <a:extLst xmlns:a="http://schemas.openxmlformats.org/drawingml/2006/main">
               <a:ext uri="{FF2B5EF4-FFF2-40B4-BE49-F238E27FC236}">
-                <a16:creationId xmlns:a16="http://schemas.microsoft.com/office/drawing/2014/main" id="{CE9A419B-3580-4573-A169-277F0E9698F5}"/>
+                <a16:creationId xmlns:a16="http://schemas.microsoft.com/office/drawing/2014/main" id="{F1EAB744-9E32-4E00-BDAE-15CB2CE6C313}"/>
               </a:ext>
             </a:extLst>
           </p:cNvPr>
@@ -1909,7 +1909,7 @@
           <p:cNvPr id="17" name="2-Data and denominators-body">
             <a:extLst xmlns:a="http://schemas.openxmlformats.org/drawingml/2006/main">
               <a:ext uri="{FF2B5EF4-FFF2-40B4-BE49-F238E27FC236}">
-                <a16:creationId xmlns:a16="http://schemas.microsoft.com/office/drawing/2014/main" id="{4DD2DBBE-4BFA-4B13-A8C0-7B1914EE99A9}"/>
+                <a16:creationId xmlns:a16="http://schemas.microsoft.com/office/drawing/2014/main" id="{7F6C8A0A-362C-46A4-BD1B-DB0D26D10D14}"/>
               </a:ext>
             </a:extLst>
           </p:cNvPr>
@@ -1993,7 +1993,7 @@
           <p:cNvPr id="18" name="3-Why beta CIs?-box">
             <a:extLst xmlns:a="http://schemas.openxmlformats.org/drawingml/2006/main">
               <a:ext uri="{FF2B5EF4-FFF2-40B4-BE49-F238E27FC236}">
-                <a16:creationId xmlns:a16="http://schemas.microsoft.com/office/drawing/2014/main" id="{81397162-AB87-42E2-80A5-2C76517A6837}"/>
+                <a16:creationId xmlns:a16="http://schemas.microsoft.com/office/drawing/2014/main" id="{5C5CE4BE-56FA-43AB-AD32-F67A8C47526C}"/>
               </a:ext>
             </a:extLst>
           </p:cNvPr>
@@ -2026,7 +2026,7 @@
           <p:cNvPr id="19" name="3-Why beta CIs?-head">
             <a:extLst xmlns:a="http://schemas.openxmlformats.org/drawingml/2006/main">
               <a:ext uri="{FF2B5EF4-FFF2-40B4-BE49-F238E27FC236}">
-                <a16:creationId xmlns:a16="http://schemas.microsoft.com/office/drawing/2014/main" id="{5F079014-5C9E-4CD1-9F57-06B0FFF4D66E}"/>
+                <a16:creationId xmlns:a16="http://schemas.microsoft.com/office/drawing/2014/main" id="{083D677C-83C7-4B08-90E2-25DB05038CCA}"/>
               </a:ext>
             </a:extLst>
           </p:cNvPr>
@@ -2059,7 +2059,7 @@
           <p:cNvPr id="20" name="3-Why beta CIs?-title">
             <a:extLst xmlns:a="http://schemas.openxmlformats.org/drawingml/2006/main">
               <a:ext uri="{FF2B5EF4-FFF2-40B4-BE49-F238E27FC236}">
-                <a16:creationId xmlns:a16="http://schemas.microsoft.com/office/drawing/2014/main" id="{EA1F153F-399E-4043-85AB-C7C11502A03B}"/>
+                <a16:creationId xmlns:a16="http://schemas.microsoft.com/office/drawing/2014/main" id="{FF5CBAFC-45F1-40F5-B72E-6E04A35CE8B5}"/>
               </a:ext>
             </a:extLst>
           </p:cNvPr>
@@ -2109,7 +2109,7 @@
           <p:cNvPr id="21" name="3-Why beta CIs?-body">
             <a:extLst xmlns:a="http://schemas.openxmlformats.org/drawingml/2006/main">
               <a:ext uri="{FF2B5EF4-FFF2-40B4-BE49-F238E27FC236}">
-                <a16:creationId xmlns:a16="http://schemas.microsoft.com/office/drawing/2014/main" id="{886F9400-B1A8-4C70-A74E-2CE58923427E}"/>
+                <a16:creationId xmlns:a16="http://schemas.microsoft.com/office/drawing/2014/main" id="{2AEE2BD1-93C7-4AB7-A6B4-0E9AC23D77D1}"/>
               </a:ext>
             </a:extLst>
           </p:cNvPr>
@@ -2193,7 +2193,7 @@
           <p:cNvPr id="22" name="4-ETL and interoperability-box">
             <a:extLst xmlns:a="http://schemas.openxmlformats.org/drawingml/2006/main">
               <a:ext uri="{FF2B5EF4-FFF2-40B4-BE49-F238E27FC236}">
-                <a16:creationId xmlns:a16="http://schemas.microsoft.com/office/drawing/2014/main" id="{6C15C9A4-0FC0-4F0B-B888-79D9C36E40E7}"/>
+                <a16:creationId xmlns:a16="http://schemas.microsoft.com/office/drawing/2014/main" id="{E5A74190-FF12-40FE-9A53-A273C64E66EC}"/>
               </a:ext>
             </a:extLst>
           </p:cNvPr>
@@ -2226,7 +2226,7 @@
           <p:cNvPr id="23" name="4-ETL and interoperability-head">
             <a:extLst xmlns:a="http://schemas.openxmlformats.org/drawingml/2006/main">
               <a:ext uri="{FF2B5EF4-FFF2-40B4-BE49-F238E27FC236}">
-                <a16:creationId xmlns:a16="http://schemas.microsoft.com/office/drawing/2014/main" id="{72A0C436-CC38-4927-A1F7-65CA88B6CBDE}"/>
+                <a16:creationId xmlns:a16="http://schemas.microsoft.com/office/drawing/2014/main" id="{01B0D6E7-69DC-430F-90BE-CA00726B84BF}"/>
               </a:ext>
             </a:extLst>
           </p:cNvPr>
@@ -2259,7 +2259,7 @@
           <p:cNvPr id="24" name="4-ETL and interoperability-title">
             <a:extLst xmlns:a="http://schemas.openxmlformats.org/drawingml/2006/main">
               <a:ext uri="{FF2B5EF4-FFF2-40B4-BE49-F238E27FC236}">
-                <a16:creationId xmlns:a16="http://schemas.microsoft.com/office/drawing/2014/main" id="{6DB66DD0-731B-47A8-BBCD-63C22D13E169}"/>
+                <a16:creationId xmlns:a16="http://schemas.microsoft.com/office/drawing/2014/main" id="{4CA2634C-7B1F-4C30-A306-A60DB8FE1C43}"/>
               </a:ext>
             </a:extLst>
           </p:cNvPr>
@@ -2309,7 +2309,7 @@
           <p:cNvPr id="25" name="4-ETL and interoperability-body">
             <a:extLst xmlns:a="http://schemas.openxmlformats.org/drawingml/2006/main">
               <a:ext uri="{FF2B5EF4-FFF2-40B4-BE49-F238E27FC236}">
-                <a16:creationId xmlns:a16="http://schemas.microsoft.com/office/drawing/2014/main" id="{19E81CA4-33B8-41BC-B388-DAB8C71C3AFA}"/>
+                <a16:creationId xmlns:a16="http://schemas.microsoft.com/office/drawing/2014/main" id="{5724804C-FCA1-49CB-B1E8-DB5141595CD1}"/>
               </a:ext>
             </a:extLst>
           </p:cNvPr>
@@ -2393,7 +2393,7 @@
           <p:cNvPr id="26" name="m-prev-metric">
             <a:extLst xmlns:a="http://schemas.openxmlformats.org/drawingml/2006/main">
               <a:ext uri="{FF2B5EF4-FFF2-40B4-BE49-F238E27FC236}">
-                <a16:creationId xmlns:a16="http://schemas.microsoft.com/office/drawing/2014/main" id="{19418887-6E00-4DC5-AF6D-CECF522BA69E}"/>
+                <a16:creationId xmlns:a16="http://schemas.microsoft.com/office/drawing/2014/main" id="{156AF691-ADC5-42E5-B614-E74B9A839ACA}"/>
               </a:ext>
             </a:extLst>
           </p:cNvPr>
@@ -2426,7 +2426,7 @@
           <p:cNvPr id="27" name="m-prev-metric-title">
             <a:extLst xmlns:a="http://schemas.openxmlformats.org/drawingml/2006/main">
               <a:ext uri="{FF2B5EF4-FFF2-40B4-BE49-F238E27FC236}">
-                <a16:creationId xmlns:a16="http://schemas.microsoft.com/office/drawing/2014/main" id="{4C9EB2CD-03EE-4B42-B4D8-33BB952D23DD}"/>
+                <a16:creationId xmlns:a16="http://schemas.microsoft.com/office/drawing/2014/main" id="{38EA17E6-C82F-438F-A230-E3E8EFEE031D}"/>
               </a:ext>
             </a:extLst>
           </p:cNvPr>
@@ -2476,7 +2476,7 @@
           <p:cNvPr id="28" name="m-prev-metric-value">
             <a:extLst xmlns:a="http://schemas.openxmlformats.org/drawingml/2006/main">
               <a:ext uri="{FF2B5EF4-FFF2-40B4-BE49-F238E27FC236}">
-                <a16:creationId xmlns:a16="http://schemas.microsoft.com/office/drawing/2014/main" id="{3B1A7F83-7848-4E52-B074-1E7F8A6FDE98}"/>
+                <a16:creationId xmlns:a16="http://schemas.microsoft.com/office/drawing/2014/main" id="{5F288295-A5F2-4898-A86D-00FAA03496B7}"/>
               </a:ext>
             </a:extLst>
           </p:cNvPr>
@@ -2526,7 +2526,7 @@
           <p:cNvPr id="29" name="m-prev-metric-note">
             <a:extLst xmlns:a="http://schemas.openxmlformats.org/drawingml/2006/main">
               <a:ext uri="{FF2B5EF4-FFF2-40B4-BE49-F238E27FC236}">
-                <a16:creationId xmlns:a16="http://schemas.microsoft.com/office/drawing/2014/main" id="{39C1162C-EA0D-4D15-BF06-2EBFCAA3017A}"/>
+                <a16:creationId xmlns:a16="http://schemas.microsoft.com/office/drawing/2014/main" id="{CC2F7066-DB8E-4C85-A375-FBFB2B187847}"/>
               </a:ext>
             </a:extLst>
           </p:cNvPr>
@@ -2576,7 +2576,7 @@
           <p:cNvPr id="30" name="m-crisis-metric">
             <a:extLst xmlns:a="http://schemas.openxmlformats.org/drawingml/2006/main">
               <a:ext uri="{FF2B5EF4-FFF2-40B4-BE49-F238E27FC236}">
-                <a16:creationId xmlns:a16="http://schemas.microsoft.com/office/drawing/2014/main" id="{0CAC820D-B22E-42B0-B204-0062F3482AAE}"/>
+                <a16:creationId xmlns:a16="http://schemas.microsoft.com/office/drawing/2014/main" id="{539CBC50-29D8-4498-A82F-77998A4BA70A}"/>
               </a:ext>
             </a:extLst>
           </p:cNvPr>
@@ -2609,7 +2609,7 @@
           <p:cNvPr id="31" name="m-crisis-metric-title">
             <a:extLst xmlns:a="http://schemas.openxmlformats.org/drawingml/2006/main">
               <a:ext uri="{FF2B5EF4-FFF2-40B4-BE49-F238E27FC236}">
-                <a16:creationId xmlns:a16="http://schemas.microsoft.com/office/drawing/2014/main" id="{DD18DEA2-FC70-4A94-BEC6-9F5B0B8DC4EA}"/>
+                <a16:creationId xmlns:a16="http://schemas.microsoft.com/office/drawing/2014/main" id="{9AA98652-439A-440E-8365-B40AED96E477}"/>
               </a:ext>
             </a:extLst>
           </p:cNvPr>
@@ -2659,7 +2659,7 @@
           <p:cNvPr id="32" name="m-crisis-metric-value">
             <a:extLst xmlns:a="http://schemas.openxmlformats.org/drawingml/2006/main">
               <a:ext uri="{FF2B5EF4-FFF2-40B4-BE49-F238E27FC236}">
-                <a16:creationId xmlns:a16="http://schemas.microsoft.com/office/drawing/2014/main" id="{7B1AC243-C68D-4F79-B487-A16283C32AE1}"/>
+                <a16:creationId xmlns:a16="http://schemas.microsoft.com/office/drawing/2014/main" id="{F7479AE7-520B-4A49-B80A-2B30F612FBAB}"/>
               </a:ext>
             </a:extLst>
           </p:cNvPr>
@@ -2709,7 +2709,7 @@
           <p:cNvPr id="33" name="m-crisis-metric-note">
             <a:extLst xmlns:a="http://schemas.openxmlformats.org/drawingml/2006/main">
               <a:ext uri="{FF2B5EF4-FFF2-40B4-BE49-F238E27FC236}">
-                <a16:creationId xmlns:a16="http://schemas.microsoft.com/office/drawing/2014/main" id="{42DECB49-3C0E-419D-A07B-5051A287EA4C}"/>
+                <a16:creationId xmlns:a16="http://schemas.microsoft.com/office/drawing/2014/main" id="{CF049EC0-B815-42EB-A61B-A106C50FAF27}"/>
               </a:ext>
             </a:extLst>
           </p:cNvPr>
@@ -2759,7 +2759,7 @@
           <p:cNvPr id="34" name="m-meds-metric">
             <a:extLst xmlns:a="http://schemas.openxmlformats.org/drawingml/2006/main">
               <a:ext uri="{FF2B5EF4-FFF2-40B4-BE49-F238E27FC236}">
-                <a16:creationId xmlns:a16="http://schemas.microsoft.com/office/drawing/2014/main" id="{6508A0B7-DD24-4E33-9A60-A99A32177C94}"/>
+                <a16:creationId xmlns:a16="http://schemas.microsoft.com/office/drawing/2014/main" id="{6989049D-E071-49D5-978C-C39DDE408D21}"/>
               </a:ext>
             </a:extLst>
           </p:cNvPr>
@@ -2792,7 +2792,7 @@
           <p:cNvPr id="35" name="m-meds-metric-title">
             <a:extLst xmlns:a="http://schemas.openxmlformats.org/drawingml/2006/main">
               <a:ext uri="{FF2B5EF4-FFF2-40B4-BE49-F238E27FC236}">
-                <a16:creationId xmlns:a16="http://schemas.microsoft.com/office/drawing/2014/main" id="{D875C4CD-7936-48B8-97D2-B4FA79E13130}"/>
+                <a16:creationId xmlns:a16="http://schemas.microsoft.com/office/drawing/2014/main" id="{B1D7F53D-91CE-44B3-B3E1-FDCD2E406575}"/>
               </a:ext>
             </a:extLst>
           </p:cNvPr>
@@ -2842,7 +2842,7 @@
           <p:cNvPr id="36" name="m-meds-metric-value">
             <a:extLst xmlns:a="http://schemas.openxmlformats.org/drawingml/2006/main">
               <a:ext uri="{FF2B5EF4-FFF2-40B4-BE49-F238E27FC236}">
-                <a16:creationId xmlns:a16="http://schemas.microsoft.com/office/drawing/2014/main" id="{FD066432-AD49-408A-BBDD-45DF5BD2A22B}"/>
+                <a16:creationId xmlns:a16="http://schemas.microsoft.com/office/drawing/2014/main" id="{2B602034-55A1-4FDE-8495-24C7B65587D2}"/>
               </a:ext>
             </a:extLst>
           </p:cNvPr>
@@ -2892,7 +2892,7 @@
           <p:cNvPr id="37" name="m-meds-metric-note">
             <a:extLst xmlns:a="http://schemas.openxmlformats.org/drawingml/2006/main">
               <a:ext uri="{FF2B5EF4-FFF2-40B4-BE49-F238E27FC236}">
-                <a16:creationId xmlns:a16="http://schemas.microsoft.com/office/drawing/2014/main" id="{E0AA9C00-923C-4433-A025-EBDA14948AB3}"/>
+                <a16:creationId xmlns:a16="http://schemas.microsoft.com/office/drawing/2014/main" id="{20EEB764-B36C-49C7-8783-51516CC5E1AD}"/>
               </a:ext>
             </a:extLst>
           </p:cNvPr>
@@ -2942,7 +2942,7 @@
           <p:cNvPr id="38" name="m-chart-prev-caption">
             <a:extLst xmlns:a="http://schemas.openxmlformats.org/drawingml/2006/main">
               <a:ext uri="{FF2B5EF4-FFF2-40B4-BE49-F238E27FC236}">
-                <a16:creationId xmlns:a16="http://schemas.microsoft.com/office/drawing/2014/main" id="{078FAEE1-21F7-4416-BCBE-C3C84F9B7E7E}"/>
+                <a16:creationId xmlns:a16="http://schemas.microsoft.com/office/drawing/2014/main" id="{DCB583D3-9BB1-463B-B346-65994E940299}"/>
               </a:ext>
             </a:extLst>
           </p:cNvPr>
@@ -2992,7 +2992,7 @@
           <p:cNvPr id="39" name="m-chart-prev-frame">
             <a:extLst xmlns:a="http://schemas.openxmlformats.org/drawingml/2006/main">
               <a:ext uri="{FF2B5EF4-FFF2-40B4-BE49-F238E27FC236}">
-                <a16:creationId xmlns:a16="http://schemas.microsoft.com/office/drawing/2014/main" id="{D831F4D4-6189-4F24-8FD6-77E6EBBE70DE}"/>
+                <a16:creationId xmlns:a16="http://schemas.microsoft.com/office/drawing/2014/main" id="{97E8D029-15CD-41E5-9DE4-8F1016DA6488}"/>
               </a:ext>
             </a:extLst>
           </p:cNvPr>
@@ -3022,14 +3022,14 @@
       </p:sp>
       <p:pic>
         <p:nvPicPr>
-          <p:cNvPr id="104" name=""/>
+          <p:cNvPr id="105" name=""/>
           <p:cNvPicPr>
             <a:picLocks xmlns:a="http://schemas.openxmlformats.org/drawingml/2006/main" noChangeAspect="1"/>
           </p:cNvPicPr>
           <p:nvPr/>
         </p:nvPicPr>
         <p:blipFill>
-          <a:blip xmlns:r="http://schemas.openxmlformats.org/officeDocument/2006/relationships" xmlns:a="http://schemas.openxmlformats.org/drawingml/2006/main" r:embed="Raf9be7e708f94b94"/>
+          <a:blip xmlns:r="http://schemas.openxmlformats.org/officeDocument/2006/relationships" xmlns:a="http://schemas.openxmlformats.org/drawingml/2006/main" r:embed="Rbd78dc13921b45ff"/>
           <a:stretch xmlns:a="http://schemas.openxmlformats.org/drawingml/2006/main"/>
         </p:blipFill>
         <p:spPr>
@@ -3047,7 +3047,7 @@
           <p:cNvPr id="41" name="m-chart-meds-caption">
             <a:extLst xmlns:a="http://schemas.openxmlformats.org/drawingml/2006/main">
               <a:ext uri="{FF2B5EF4-FFF2-40B4-BE49-F238E27FC236}">
-                <a16:creationId xmlns:a16="http://schemas.microsoft.com/office/drawing/2014/main" id="{154855AF-2E0A-4633-9AE6-825357B850E5}"/>
+                <a16:creationId xmlns:a16="http://schemas.microsoft.com/office/drawing/2014/main" id="{EA7896E7-F231-4D3E-8835-EC475FAE6301}"/>
               </a:ext>
             </a:extLst>
           </p:cNvPr>
@@ -3097,7 +3097,7 @@
           <p:cNvPr id="42" name="m-chart-meds-frame">
             <a:extLst xmlns:a="http://schemas.openxmlformats.org/drawingml/2006/main">
               <a:ext uri="{FF2B5EF4-FFF2-40B4-BE49-F238E27FC236}">
-                <a16:creationId xmlns:a16="http://schemas.microsoft.com/office/drawing/2014/main" id="{1613E63B-AECC-4D56-81DF-D2BC8E0A000E}"/>
+                <a16:creationId xmlns:a16="http://schemas.microsoft.com/office/drawing/2014/main" id="{D6CD4B8D-3EDD-4548-B379-801376B59391}"/>
               </a:ext>
             </a:extLst>
           </p:cNvPr>
@@ -3127,14 +3127,14 @@
       </p:sp>
       <p:pic>
         <p:nvPicPr>
-          <p:cNvPr id="107" name=""/>
+          <p:cNvPr id="108" name=""/>
           <p:cNvPicPr>
             <a:picLocks xmlns:a="http://schemas.openxmlformats.org/drawingml/2006/main" noChangeAspect="1"/>
           </p:cNvPicPr>
           <p:nvPr/>
         </p:nvPicPr>
         <p:blipFill>
-          <a:blip xmlns:r="http://schemas.openxmlformats.org/officeDocument/2006/relationships" xmlns:a="http://schemas.openxmlformats.org/drawingml/2006/main" r:embed="R828062c8adea47db"/>
+          <a:blip xmlns:r="http://schemas.openxmlformats.org/officeDocument/2006/relationships" xmlns:a="http://schemas.openxmlformats.org/drawingml/2006/main" r:embed="R08da982c6c93425c"/>
           <a:stretch xmlns:a="http://schemas.openxmlformats.org/drawingml/2006/main"/>
         </p:blipFill>
         <p:spPr>
@@ -3152,7 +3152,7 @@
           <p:cNvPr id="44" name="m-chart-smoke-caption">
             <a:extLst xmlns:a="http://schemas.openxmlformats.org/drawingml/2006/main">
               <a:ext uri="{FF2B5EF4-FFF2-40B4-BE49-F238E27FC236}">
-                <a16:creationId xmlns:a16="http://schemas.microsoft.com/office/drawing/2014/main" id="{B670413F-8EBB-40F2-A86A-C6A0855BE7EA}"/>
+                <a16:creationId xmlns:a16="http://schemas.microsoft.com/office/drawing/2014/main" id="{3392650B-1626-4AD3-83C2-9BCAF6A7CEC2}"/>
               </a:ext>
             </a:extLst>
           </p:cNvPr>
@@ -3202,7 +3202,7 @@
           <p:cNvPr id="45" name="m-chart-smoke-frame">
             <a:extLst xmlns:a="http://schemas.openxmlformats.org/drawingml/2006/main">
               <a:ext uri="{FF2B5EF4-FFF2-40B4-BE49-F238E27FC236}">
-                <a16:creationId xmlns:a16="http://schemas.microsoft.com/office/drawing/2014/main" id="{3A6BC5B3-75D3-4D97-A625-1B1429B7E413}"/>
+                <a16:creationId xmlns:a16="http://schemas.microsoft.com/office/drawing/2014/main" id="{9FE1B11F-8C87-4229-B6FE-26A20C5F35B7}"/>
               </a:ext>
             </a:extLst>
           </p:cNvPr>
@@ -3232,14 +3232,14 @@
       </p:sp>
       <p:pic>
         <p:nvPicPr>
-          <p:cNvPr id="110" name=""/>
+          <p:cNvPr id="111" name=""/>
           <p:cNvPicPr>
             <a:picLocks xmlns:a="http://schemas.openxmlformats.org/drawingml/2006/main" noChangeAspect="1"/>
           </p:cNvPicPr>
           <p:nvPr/>
         </p:nvPicPr>
         <p:blipFill>
-          <a:blip xmlns:r="http://schemas.openxmlformats.org/officeDocument/2006/relationships" xmlns:a="http://schemas.openxmlformats.org/drawingml/2006/main" r:embed="R4f738cbadf1d4ac5"/>
+          <a:blip xmlns:r="http://schemas.openxmlformats.org/officeDocument/2006/relationships" xmlns:a="http://schemas.openxmlformats.org/drawingml/2006/main" r:embed="R4ff1207bcae14798"/>
           <a:stretch xmlns:a="http://schemas.openxmlformats.org/drawingml/2006/main"/>
         </p:blipFill>
         <p:spPr>
@@ -3257,7 +3257,7 @@
           <p:cNvPr id="47" name="5-Discussion-box">
             <a:extLst xmlns:a="http://schemas.openxmlformats.org/drawingml/2006/main">
               <a:ext uri="{FF2B5EF4-FFF2-40B4-BE49-F238E27FC236}">
-                <a16:creationId xmlns:a16="http://schemas.microsoft.com/office/drawing/2014/main" id="{279DD782-CC00-42F2-A69A-CCC1DEA9B9BF}"/>
+                <a16:creationId xmlns:a16="http://schemas.microsoft.com/office/drawing/2014/main" id="{16DEE12B-26FB-4E90-9F53-35715C7BAEE9}"/>
               </a:ext>
             </a:extLst>
           </p:cNvPr>
@@ -3290,7 +3290,7 @@
           <p:cNvPr id="48" name="5-Discussion-head">
             <a:extLst xmlns:a="http://schemas.openxmlformats.org/drawingml/2006/main">
               <a:ext uri="{FF2B5EF4-FFF2-40B4-BE49-F238E27FC236}">
-                <a16:creationId xmlns:a16="http://schemas.microsoft.com/office/drawing/2014/main" id="{EC62A2EC-8F23-446E-A94D-39C57AEEA9B7}"/>
+                <a16:creationId xmlns:a16="http://schemas.microsoft.com/office/drawing/2014/main" id="{C0BA6549-03B3-4C1C-A6FA-1AC2A26213BB}"/>
               </a:ext>
             </a:extLst>
           </p:cNvPr>
@@ -3323,7 +3323,7 @@
           <p:cNvPr id="49" name="5-Discussion-title">
             <a:extLst xmlns:a="http://schemas.openxmlformats.org/drawingml/2006/main">
               <a:ext uri="{FF2B5EF4-FFF2-40B4-BE49-F238E27FC236}">
-                <a16:creationId xmlns:a16="http://schemas.microsoft.com/office/drawing/2014/main" id="{D3217D52-F1DD-4E9C-8803-08D0F1AE730E}"/>
+                <a16:creationId xmlns:a16="http://schemas.microsoft.com/office/drawing/2014/main" id="{C24D4A0E-B236-4B90-84A4-F9F602728D7E}"/>
               </a:ext>
             </a:extLst>
           </p:cNvPr>
@@ -3373,7 +3373,7 @@
           <p:cNvPr id="50" name="5-Discussion-body">
             <a:extLst xmlns:a="http://schemas.openxmlformats.org/drawingml/2006/main">
               <a:ext uri="{FF2B5EF4-FFF2-40B4-BE49-F238E27FC236}">
-                <a16:creationId xmlns:a16="http://schemas.microsoft.com/office/drawing/2014/main" id="{40F3F5A8-2246-4BC8-9652-C901BEE89778}"/>
+                <a16:creationId xmlns:a16="http://schemas.microsoft.com/office/drawing/2014/main" id="{DEA1BB08-5D20-40CA-8A2D-BF377F9D3426}"/>
               </a:ext>
             </a:extLst>
           </p:cNvPr>
@@ -3525,7 +3525,7 @@
           <p:cNvPr id="51" name="6-Central conclusion-box">
             <a:extLst xmlns:a="http://schemas.openxmlformats.org/drawingml/2006/main">
               <a:ext uri="{FF2B5EF4-FFF2-40B4-BE49-F238E27FC236}">
-                <a16:creationId xmlns:a16="http://schemas.microsoft.com/office/drawing/2014/main" id="{8064B8CC-D2FD-4F38-8516-22C704A3B7CE}"/>
+                <a16:creationId xmlns:a16="http://schemas.microsoft.com/office/drawing/2014/main" id="{6FF2F46E-BF10-4457-843F-F3D8C9F77EC1}"/>
               </a:ext>
             </a:extLst>
           </p:cNvPr>
@@ -3558,7 +3558,7 @@
           <p:cNvPr id="52" name="6-Central conclusion-head">
             <a:extLst xmlns:a="http://schemas.openxmlformats.org/drawingml/2006/main">
               <a:ext uri="{FF2B5EF4-FFF2-40B4-BE49-F238E27FC236}">
-                <a16:creationId xmlns:a16="http://schemas.microsoft.com/office/drawing/2014/main" id="{C0580B82-5B59-4B7B-B101-7B700AA96399}"/>
+                <a16:creationId xmlns:a16="http://schemas.microsoft.com/office/drawing/2014/main" id="{1569AD37-994C-4DF2-926B-762772E68F1C}"/>
               </a:ext>
             </a:extLst>
           </p:cNvPr>
@@ -3591,7 +3591,7 @@
           <p:cNvPr id="53" name="6-Central conclusion-title">
             <a:extLst xmlns:a="http://schemas.openxmlformats.org/drawingml/2006/main">
               <a:ext uri="{FF2B5EF4-FFF2-40B4-BE49-F238E27FC236}">
-                <a16:creationId xmlns:a16="http://schemas.microsoft.com/office/drawing/2014/main" id="{0B09E707-ED2C-4F56-AA2E-2B53802252E1}"/>
+                <a16:creationId xmlns:a16="http://schemas.microsoft.com/office/drawing/2014/main" id="{6A04E2C4-3120-4DFD-A05D-B898F1666890}"/>
               </a:ext>
             </a:extLst>
           </p:cNvPr>
@@ -3641,7 +3641,7 @@
           <p:cNvPr id="54" name="6-Central conclusion-body">
             <a:extLst xmlns:a="http://schemas.openxmlformats.org/drawingml/2006/main">
               <a:ext uri="{FF2B5EF4-FFF2-40B4-BE49-F238E27FC236}">
-                <a16:creationId xmlns:a16="http://schemas.microsoft.com/office/drawing/2014/main" id="{78B59DD8-603A-40A3-82FA-62603D069B44}"/>
+                <a16:creationId xmlns:a16="http://schemas.microsoft.com/office/drawing/2014/main" id="{CEF92151-244C-40ED-8C83-1306B6310E51}"/>
               </a:ext>
             </a:extLst>
           </p:cNvPr>
@@ -3725,7 +3725,7 @@
           <p:cNvPr id="55" name="m-chart-crisis-caption">
             <a:extLst xmlns:a="http://schemas.openxmlformats.org/drawingml/2006/main">
               <a:ext uri="{FF2B5EF4-FFF2-40B4-BE49-F238E27FC236}">
-                <a16:creationId xmlns:a16="http://schemas.microsoft.com/office/drawing/2014/main" id="{48B738B6-120F-4214-B588-E2B392962CA8}"/>
+                <a16:creationId xmlns:a16="http://schemas.microsoft.com/office/drawing/2014/main" id="{8D88A9D7-7B90-4ED2-ACA5-D679EB4BBCCA}"/>
               </a:ext>
             </a:extLst>
           </p:cNvPr>
@@ -3775,7 +3775,7 @@
           <p:cNvPr id="56" name="m-chart-crisis-frame">
             <a:extLst xmlns:a="http://schemas.openxmlformats.org/drawingml/2006/main">
               <a:ext uri="{FF2B5EF4-FFF2-40B4-BE49-F238E27FC236}">
-                <a16:creationId xmlns:a16="http://schemas.microsoft.com/office/drawing/2014/main" id="{4E115667-5D00-43FB-82C7-108BFFDC32F8}"/>
+                <a16:creationId xmlns:a16="http://schemas.microsoft.com/office/drawing/2014/main" id="{45B61A25-18C8-424A-9997-40570D763010}"/>
               </a:ext>
             </a:extLst>
           </p:cNvPr>
@@ -3805,14 +3805,14 @@
       </p:sp>
       <p:pic>
         <p:nvPicPr>
-          <p:cNvPr id="121" name=""/>
+          <p:cNvPr id="122" name=""/>
           <p:cNvPicPr>
             <a:picLocks xmlns:a="http://schemas.openxmlformats.org/drawingml/2006/main" noChangeAspect="1"/>
           </p:cNvPicPr>
           <p:nvPr/>
         </p:nvPicPr>
         <p:blipFill>
-          <a:blip xmlns:r="http://schemas.openxmlformats.org/officeDocument/2006/relationships" xmlns:a="http://schemas.openxmlformats.org/drawingml/2006/main" r:embed="Rf0ec58bd9175458b"/>
+          <a:blip xmlns:r="http://schemas.openxmlformats.org/officeDocument/2006/relationships" xmlns:a="http://schemas.openxmlformats.org/drawingml/2006/main" r:embed="R55e353833170445d"/>
           <a:stretch xmlns:a="http://schemas.openxmlformats.org/drawingml/2006/main"/>
         </p:blipFill>
         <p:spPr>
@@ -3830,7 +3830,7 @@
           <p:cNvPr id="58" name="qr-box">
             <a:extLst xmlns:a="http://schemas.openxmlformats.org/drawingml/2006/main">
               <a:ext uri="{FF2B5EF4-FFF2-40B4-BE49-F238E27FC236}">
-                <a16:creationId xmlns:a16="http://schemas.microsoft.com/office/drawing/2014/main" id="{BFC05223-5456-4CBD-ACC8-2DEFB8252737}"/>
+                <a16:creationId xmlns:a16="http://schemas.microsoft.com/office/drawing/2014/main" id="{CACE5E85-F793-473D-A342-F244D09CA28C}"/>
               </a:ext>
             </a:extLst>
           </p:cNvPr>
@@ -3860,14 +3860,14 @@
       </p:sp>
       <p:pic>
         <p:nvPicPr>
-          <p:cNvPr id="123" name=""/>
+          <p:cNvPr id="124" name=""/>
           <p:cNvPicPr>
             <a:picLocks xmlns:a="http://schemas.openxmlformats.org/drawingml/2006/main" noChangeAspect="1"/>
           </p:cNvPicPr>
           <p:nvPr/>
         </p:nvPicPr>
         <p:blipFill>
-          <a:blip xmlns:r="http://schemas.openxmlformats.org/officeDocument/2006/relationships" xmlns:a="http://schemas.openxmlformats.org/drawingml/2006/main" r:embed="R75bcb6c6532d4acc"/>
+          <a:blip xmlns:r="http://schemas.openxmlformats.org/officeDocument/2006/relationships" xmlns:a="http://schemas.openxmlformats.org/drawingml/2006/main" r:embed="R40b246558cb54e59"/>
           <a:stretch xmlns:a="http://schemas.openxmlformats.org/drawingml/2006/main"/>
         </p:blipFill>
         <p:spPr>
@@ -3885,7 +3885,7 @@
           <p:cNvPr id="60" name="qr-label">
             <a:extLst xmlns:a="http://schemas.openxmlformats.org/drawingml/2006/main">
               <a:ext uri="{FF2B5EF4-FFF2-40B4-BE49-F238E27FC236}">
-                <a16:creationId xmlns:a16="http://schemas.microsoft.com/office/drawing/2014/main" id="{977B54EA-87DB-406A-BE9C-201130A01479}"/>
+                <a16:creationId xmlns:a16="http://schemas.microsoft.com/office/drawing/2014/main" id="{9131A340-FFCF-40BD-880E-AB509AAB8F31}"/>
               </a:ext>
             </a:extLst>
           </p:cNvPr>
@@ -3952,19 +3952,19 @@
           <p:cNvPr id="61" name="references-box">
             <a:extLst xmlns:a="http://schemas.openxmlformats.org/drawingml/2006/main">
               <a:ext uri="{FF2B5EF4-FFF2-40B4-BE49-F238E27FC236}">
-                <a16:creationId xmlns:a16="http://schemas.microsoft.com/office/drawing/2014/main" id="{5B82C0EB-7D43-4F3A-B51B-6E2E479FCD96}"/>
-              </a:ext>
-            </a:extLst>
-          </p:cNvPr>
-          <p:cNvSpPr>
-            <a:spLocks xmlns:a="http://schemas.openxmlformats.org/drawingml/2006/main" noGrp="1"/>
-          </p:cNvSpPr>
-          <p:nvPr/>
-        </p:nvSpPr>
-        <p:spPr>
-          <a:xfrm xmlns:a="http://schemas.openxmlformats.org/drawingml/2006/main">
-            <a:off x="323850" y="12382500"/>
-            <a:ext cx="8877300" cy="857250"/>
+                <a16:creationId xmlns:a16="http://schemas.microsoft.com/office/drawing/2014/main" id="{6085C1B3-CFAA-4876-812E-3C6510C7DBF8}"/>
+              </a:ext>
+            </a:extLst>
+          </p:cNvPr>
+          <p:cNvSpPr>
+            <a:spLocks xmlns:a="http://schemas.openxmlformats.org/drawingml/2006/main" noGrp="1"/>
+          </p:cNvSpPr>
+          <p:nvPr/>
+        </p:nvSpPr>
+        <p:spPr>
+          <a:xfrm xmlns:a="http://schemas.openxmlformats.org/drawingml/2006/main">
+            <a:off x="323850" y="12268200"/>
+            <a:ext cx="8877300" cy="1066800"/>
           </a:xfrm>
           <a:prstGeom xmlns:a="http://schemas.openxmlformats.org/drawingml/2006/main" prst="rect">
             <a:avLst/>
@@ -3985,18 +3985,18 @@
           <p:cNvPr id="62" name="references-title">
             <a:extLst xmlns:a="http://schemas.openxmlformats.org/drawingml/2006/main">
               <a:ext uri="{FF2B5EF4-FFF2-40B4-BE49-F238E27FC236}">
-                <a16:creationId xmlns:a16="http://schemas.microsoft.com/office/drawing/2014/main" id="{233B0604-2EBB-4DCE-B750-A3D7499341B4}"/>
-              </a:ext>
-            </a:extLst>
-          </p:cNvPr>
-          <p:cNvSpPr>
-            <a:spLocks xmlns:a="http://schemas.openxmlformats.org/drawingml/2006/main" noGrp="1"/>
-          </p:cNvSpPr>
-          <p:nvPr/>
-        </p:nvSpPr>
-        <p:spPr>
-          <a:xfrm xmlns:a="http://schemas.openxmlformats.org/drawingml/2006/main">
-            <a:off x="400050" y="12449175"/>
+                <a16:creationId xmlns:a16="http://schemas.microsoft.com/office/drawing/2014/main" id="{E0B45362-7403-4534-9F15-98FBB85FBA3E}"/>
+              </a:ext>
+            </a:extLst>
+          </p:cNvPr>
+          <p:cNvSpPr>
+            <a:spLocks xmlns:a="http://schemas.openxmlformats.org/drawingml/2006/main" noGrp="1"/>
+          </p:cNvSpPr>
+          <p:nvPr/>
+        </p:nvSpPr>
+        <p:spPr>
+          <a:xfrm xmlns:a="http://schemas.openxmlformats.org/drawingml/2006/main">
+            <a:off x="400050" y="12334875"/>
             <a:ext cx="8724900" cy="171450"/>
           </a:xfrm>
           <a:prstGeom xmlns:a="http://schemas.openxmlformats.org/drawingml/2006/main" prst="rect">
@@ -4032,22 +4032,55 @@
       </p:sp>
       <p:sp>
         <p:nvSpPr>
-          <p:cNvPr id="63" name="references-body-left">
-            <a:extLst xmlns:a="http://schemas.openxmlformats.org/drawingml/2006/main">
-              <a:ext uri="{FF2B5EF4-FFF2-40B4-BE49-F238E27FC236}">
-                <a16:creationId xmlns:a16="http://schemas.microsoft.com/office/drawing/2014/main" id="{5B81CCD5-7703-4B69-BFA7-A72F30E9C02F}"/>
-              </a:ext>
-            </a:extLst>
-          </p:cNvPr>
-          <p:cNvSpPr>
-            <a:spLocks xmlns:a="http://schemas.openxmlformats.org/drawingml/2006/main" noGrp="1"/>
-          </p:cNvSpPr>
-          <p:nvPr/>
-        </p:nvSpPr>
-        <p:spPr>
-          <a:xfrm xmlns:a="http://schemas.openxmlformats.org/drawingml/2006/main">
-            <a:off x="400050" y="12649200"/>
-            <a:ext cx="4276725" cy="533400"/>
+          <p:cNvPr id="63" name="references-column-divider">
+            <a:extLst xmlns:a="http://schemas.openxmlformats.org/drawingml/2006/main">
+              <a:ext uri="{FF2B5EF4-FFF2-40B4-BE49-F238E27FC236}">
+                <a16:creationId xmlns:a16="http://schemas.microsoft.com/office/drawing/2014/main" id="{BE4F3F38-9D33-4F81-AA95-5CF08AC35772}"/>
+              </a:ext>
+            </a:extLst>
+          </p:cNvPr>
+          <p:cNvSpPr>
+            <a:spLocks xmlns:a="http://schemas.openxmlformats.org/drawingml/2006/main" noGrp="1"/>
+          </p:cNvSpPr>
+          <p:nvPr/>
+        </p:nvSpPr>
+        <p:spPr>
+          <a:xfrm xmlns:a="http://schemas.openxmlformats.org/drawingml/2006/main">
+            <a:off x="4762500" y="12515850"/>
+            <a:ext cx="9525" cy="762000"/>
+          </a:xfrm>
+          <a:prstGeom xmlns:a="http://schemas.openxmlformats.org/drawingml/2006/main" prst="rect">
+            <a:avLst/>
+          </a:prstGeom>
+          <a:solidFill xmlns:a="http://schemas.openxmlformats.org/drawingml/2006/main">
+            <a:srgbClr val="B7D0DF"/>
+          </a:solidFill>
+          <a:ln xmlns:a="http://schemas.openxmlformats.org/drawingml/2006/main" w="9525">
+            <a:solidFill>
+              <a:srgbClr val="B7D0DF"/>
+            </a:solidFill>
+            <a:prstDash val="solid"/>
+          </a:ln>
+        </p:spPr>
+      </p:sp>
+      <p:sp>
+        <p:nvSpPr>
+          <p:cNvPr id="64" name="references-body-left">
+            <a:extLst xmlns:a="http://schemas.openxmlformats.org/drawingml/2006/main">
+              <a:ext uri="{FF2B5EF4-FFF2-40B4-BE49-F238E27FC236}">
+                <a16:creationId xmlns:a16="http://schemas.microsoft.com/office/drawing/2014/main" id="{EAF73F07-07CD-467D-ACE5-62E29DA1A8A6}"/>
+              </a:ext>
+            </a:extLst>
+          </p:cNvPr>
+          <p:cNvSpPr>
+            <a:spLocks xmlns:a="http://schemas.openxmlformats.org/drawingml/2006/main" noGrp="1"/>
+          </p:cNvSpPr>
+          <p:nvPr/>
+        </p:nvSpPr>
+        <p:spPr>
+          <a:xfrm xmlns:a="http://schemas.openxmlformats.org/drawingml/2006/main">
+            <a:off x="400050" y="12534900"/>
+            <a:ext cx="4276725" cy="742950"/>
           </a:xfrm>
           <a:prstGeom xmlns:a="http://schemas.openxmlformats.org/drawingml/2006/main" prst="rect">
             <a:avLst/>
@@ -4063,14 +4096,14 @@
           <a:lstStyle xmlns:a="http://schemas.openxmlformats.org/drawingml/2006/main"/>
           <a:p xmlns:a="http://schemas.openxmlformats.org/drawingml/2006/main">
             <a:pPr algn="l">
-              <a:defRPr sz="368" b="0">
-                <a:solidFill>
-                  <a:srgbClr val="102536"/>
-                </a:solidFill>
-              </a:defRPr>
-            </a:pPr>
-            <a:r>
-              <a:rPr sz="368" b="0">
+              <a:defRPr sz="390" b="0">
+                <a:solidFill>
+                  <a:srgbClr val="102536"/>
+                </a:solidFill>
+              </a:defRPr>
+            </a:pPr>
+            <a:r>
+              <a:rPr sz="390" b="0">
                 <a:solidFill>
                   <a:srgbClr val="102536"/>
                 </a:solidFill>
@@ -4080,14 +4113,14 @@
           </a:p>
           <a:p xmlns:a="http://schemas.openxmlformats.org/drawingml/2006/main">
             <a:pPr algn="l">
-              <a:defRPr sz="368" b="0">
-                <a:solidFill>
-                  <a:srgbClr val="102536"/>
-                </a:solidFill>
-              </a:defRPr>
-            </a:pPr>
-            <a:r>
-              <a:rPr sz="368" b="0">
+              <a:defRPr sz="390" b="0">
+                <a:solidFill>
+                  <a:srgbClr val="102536"/>
+                </a:solidFill>
+              </a:defRPr>
+            </a:pPr>
+            <a:r>
+              <a:rPr sz="390" b="0">
                 <a:solidFill>
                   <a:srgbClr val="102536"/>
                 </a:solidFill>
@@ -4097,14 +4130,14 @@
           </a:p>
           <a:p xmlns:a="http://schemas.openxmlformats.org/drawingml/2006/main">
             <a:pPr algn="l">
-              <a:defRPr sz="368" b="0">
-                <a:solidFill>
-                  <a:srgbClr val="102536"/>
-                </a:solidFill>
-              </a:defRPr>
-            </a:pPr>
-            <a:r>
-              <a:rPr sz="368" b="0">
+              <a:defRPr sz="390" b="0">
+                <a:solidFill>
+                  <a:srgbClr val="102536"/>
+                </a:solidFill>
+              </a:defRPr>
+            </a:pPr>
+            <a:r>
+              <a:rPr sz="390" b="0">
                 <a:solidFill>
                   <a:srgbClr val="102536"/>
                 </a:solidFill>
@@ -4114,14 +4147,14 @@
           </a:p>
           <a:p xmlns:a="http://schemas.openxmlformats.org/drawingml/2006/main">
             <a:pPr algn="l">
-              <a:defRPr sz="368" b="0">
-                <a:solidFill>
-                  <a:srgbClr val="102536"/>
-                </a:solidFill>
-              </a:defRPr>
-            </a:pPr>
-            <a:r>
-              <a:rPr sz="368" b="0">
+              <a:defRPr sz="390" b="0">
+                <a:solidFill>
+                  <a:srgbClr val="102536"/>
+                </a:solidFill>
+              </a:defRPr>
+            </a:pPr>
+            <a:r>
+              <a:rPr sz="390" b="0">
                 <a:solidFill>
                   <a:srgbClr val="102536"/>
                 </a:solidFill>
@@ -4131,14 +4164,14 @@
           </a:p>
           <a:p xmlns:a="http://schemas.openxmlformats.org/drawingml/2006/main">
             <a:pPr algn="l">
-              <a:defRPr sz="368" b="0">
-                <a:solidFill>
-                  <a:srgbClr val="102536"/>
-                </a:solidFill>
-              </a:defRPr>
-            </a:pPr>
-            <a:r>
-              <a:rPr sz="368" b="0">
+              <a:defRPr sz="390" b="0">
+                <a:solidFill>
+                  <a:srgbClr val="102536"/>
+                </a:solidFill>
+              </a:defRPr>
+            </a:pPr>
+            <a:r>
+              <a:rPr sz="390" b="0">
                 <a:solidFill>
                   <a:srgbClr val="102536"/>
                 </a:solidFill>
@@ -4148,14 +4181,14 @@
           </a:p>
           <a:p xmlns:a="http://schemas.openxmlformats.org/drawingml/2006/main">
             <a:pPr algn="l">
-              <a:defRPr sz="368" b="0">
-                <a:solidFill>
-                  <a:srgbClr val="102536"/>
-                </a:solidFill>
-              </a:defRPr>
-            </a:pPr>
-            <a:r>
-              <a:rPr sz="368" b="0">
+              <a:defRPr sz="390" b="0">
+                <a:solidFill>
+                  <a:srgbClr val="102536"/>
+                </a:solidFill>
+              </a:defRPr>
+            </a:pPr>
+            <a:r>
+              <a:rPr sz="390" b="0">
                 <a:solidFill>
                   <a:srgbClr val="102536"/>
                 </a:solidFill>
@@ -4165,14 +4198,14 @@
           </a:p>
           <a:p xmlns:a="http://schemas.openxmlformats.org/drawingml/2006/main">
             <a:pPr algn="l">
-              <a:defRPr sz="368" b="0">
-                <a:solidFill>
-                  <a:srgbClr val="102536"/>
-                </a:solidFill>
-              </a:defRPr>
-            </a:pPr>
-            <a:r>
-              <a:rPr sz="368" b="0">
+              <a:defRPr sz="390" b="0">
+                <a:solidFill>
+                  <a:srgbClr val="102536"/>
+                </a:solidFill>
+              </a:defRPr>
+            </a:pPr>
+            <a:r>
+              <a:rPr sz="390" b="0">
                 <a:solidFill>
                   <a:srgbClr val="102536"/>
                 </a:solidFill>
@@ -4184,22 +4217,22 @@
       </p:sp>
       <p:sp>
         <p:nvSpPr>
-          <p:cNvPr id="64" name="references-body-right">
-            <a:extLst xmlns:a="http://schemas.openxmlformats.org/drawingml/2006/main">
-              <a:ext uri="{FF2B5EF4-FFF2-40B4-BE49-F238E27FC236}">
-                <a16:creationId xmlns:a16="http://schemas.microsoft.com/office/drawing/2014/main" id="{617868D5-6225-4B73-A46D-60CABF875A8E}"/>
-              </a:ext>
-            </a:extLst>
-          </p:cNvPr>
-          <p:cNvSpPr>
-            <a:spLocks xmlns:a="http://schemas.openxmlformats.org/drawingml/2006/main" noGrp="1"/>
-          </p:cNvSpPr>
-          <p:nvPr/>
-        </p:nvSpPr>
-        <p:spPr>
-          <a:xfrm xmlns:a="http://schemas.openxmlformats.org/drawingml/2006/main">
-            <a:off x="4848225" y="12649200"/>
-            <a:ext cx="4276725" cy="533400"/>
+          <p:cNvPr id="65" name="references-body-right">
+            <a:extLst xmlns:a="http://schemas.openxmlformats.org/drawingml/2006/main">
+              <a:ext uri="{FF2B5EF4-FFF2-40B4-BE49-F238E27FC236}">
+                <a16:creationId xmlns:a16="http://schemas.microsoft.com/office/drawing/2014/main" id="{B1CBB9CC-5454-432D-9FB5-60B904822AF6}"/>
+              </a:ext>
+            </a:extLst>
+          </p:cNvPr>
+          <p:cNvSpPr>
+            <a:spLocks xmlns:a="http://schemas.openxmlformats.org/drawingml/2006/main" noGrp="1"/>
+          </p:cNvSpPr>
+          <p:nvPr/>
+        </p:nvSpPr>
+        <p:spPr>
+          <a:xfrm xmlns:a="http://schemas.openxmlformats.org/drawingml/2006/main">
+            <a:off x="4848225" y="12534900"/>
+            <a:ext cx="4276725" cy="742950"/>
           </a:xfrm>
           <a:prstGeom xmlns:a="http://schemas.openxmlformats.org/drawingml/2006/main" prst="rect">
             <a:avLst/>
@@ -4215,14 +4248,14 @@
           <a:lstStyle xmlns:a="http://schemas.openxmlformats.org/drawingml/2006/main"/>
           <a:p xmlns:a="http://schemas.openxmlformats.org/drawingml/2006/main">
             <a:pPr algn="l">
-              <a:defRPr sz="368" b="0">
-                <a:solidFill>
-                  <a:srgbClr val="102536"/>
-                </a:solidFill>
-              </a:defRPr>
-            </a:pPr>
-            <a:r>
-              <a:rPr sz="368" b="0">
+              <a:defRPr sz="390" b="0">
+                <a:solidFill>
+                  <a:srgbClr val="102536"/>
+                </a:solidFill>
+              </a:defRPr>
+            </a:pPr>
+            <a:r>
+              <a:rPr sz="390" b="0">
                 <a:solidFill>
                   <a:srgbClr val="102536"/>
                 </a:solidFill>
@@ -4232,14 +4265,14 @@
           </a:p>
           <a:p xmlns:a="http://schemas.openxmlformats.org/drawingml/2006/main">
             <a:pPr algn="l">
-              <a:defRPr sz="368" b="0">
-                <a:solidFill>
-                  <a:srgbClr val="102536"/>
-                </a:solidFill>
-              </a:defRPr>
-            </a:pPr>
-            <a:r>
-              <a:rPr sz="368" b="0">
+              <a:defRPr sz="390" b="0">
+                <a:solidFill>
+                  <a:srgbClr val="102536"/>
+                </a:solidFill>
+              </a:defRPr>
+            </a:pPr>
+            <a:r>
+              <a:rPr sz="390" b="0">
                 <a:solidFill>
                   <a:srgbClr val="102536"/>
                 </a:solidFill>
@@ -4249,14 +4282,14 @@
           </a:p>
           <a:p xmlns:a="http://schemas.openxmlformats.org/drawingml/2006/main">
             <a:pPr algn="l">
-              <a:defRPr sz="368" b="0">
-                <a:solidFill>
-                  <a:srgbClr val="102536"/>
-                </a:solidFill>
-              </a:defRPr>
-            </a:pPr>
-            <a:r>
-              <a:rPr sz="368" b="0">
+              <a:defRPr sz="390" b="0">
+                <a:solidFill>
+                  <a:srgbClr val="102536"/>
+                </a:solidFill>
+              </a:defRPr>
+            </a:pPr>
+            <a:r>
+              <a:rPr sz="390" b="0">
                 <a:solidFill>
                   <a:srgbClr val="102536"/>
                 </a:solidFill>
@@ -4266,14 +4299,14 @@
           </a:p>
           <a:p xmlns:a="http://schemas.openxmlformats.org/drawingml/2006/main">
             <a:pPr algn="l">
-              <a:defRPr sz="368" b="0">
-                <a:solidFill>
-                  <a:srgbClr val="102536"/>
-                </a:solidFill>
-              </a:defRPr>
-            </a:pPr>
-            <a:r>
-              <a:rPr sz="368" b="0">
+              <a:defRPr sz="390" b="0">
+                <a:solidFill>
+                  <a:srgbClr val="102536"/>
+                </a:solidFill>
+              </a:defRPr>
+            </a:pPr>
+            <a:r>
+              <a:rPr sz="390" b="0">
                 <a:solidFill>
                   <a:srgbClr val="102536"/>
                 </a:solidFill>
@@ -4283,14 +4316,14 @@
           </a:p>
           <a:p xmlns:a="http://schemas.openxmlformats.org/drawingml/2006/main">
             <a:pPr algn="l">
-              <a:defRPr sz="368" b="0">
-                <a:solidFill>
-                  <a:srgbClr val="102536"/>
-                </a:solidFill>
-              </a:defRPr>
-            </a:pPr>
-            <a:r>
-              <a:rPr sz="368" b="0">
+              <a:defRPr sz="390" b="0">
+                <a:solidFill>
+                  <a:srgbClr val="102536"/>
+                </a:solidFill>
+              </a:defRPr>
+            </a:pPr>
+            <a:r>
+              <a:rPr sz="390" b="0">
                 <a:solidFill>
                   <a:srgbClr val="102536"/>
                 </a:solidFill>
@@ -4300,14 +4333,14 @@
           </a:p>
           <a:p xmlns:a="http://schemas.openxmlformats.org/drawingml/2006/main">
             <a:pPr algn="l">
-              <a:defRPr sz="368" b="0">
-                <a:solidFill>
-                  <a:srgbClr val="102536"/>
-                </a:solidFill>
-              </a:defRPr>
-            </a:pPr>
-            <a:r>
-              <a:rPr sz="368" b="0">
+              <a:defRPr sz="390" b="0">
+                <a:solidFill>
+                  <a:srgbClr val="102536"/>
+                </a:solidFill>
+              </a:defRPr>
+            </a:pPr>
+            <a:r>
+              <a:rPr sz="390" b="0">
                 <a:solidFill>
                   <a:srgbClr val="102536"/>
                 </a:solidFill>
@@ -4320,7 +4353,7 @@
     </p:spTree>
     <p:extLst>
       <p:ext uri="{BB962C8B-B14F-4D97-AF65-F5344CB8AC3E}">
-        <p14:creationId xmlns:p14="http://schemas.microsoft.com/office/powerpoint/2010/main" val="948577147"/>
+        <p14:creationId xmlns:p14="http://schemas.microsoft.com/office/powerpoint/2010/main" val="1747884301"/>
       </p:ext>
     </p:extLst>
   </p:cSld>

</xml_diff>